<commit_message>
Developed a simple GUI
</commit_message>
<xml_diff>
--- a/software architecture.pptx
+++ b/software architecture.pptx
@@ -5,8 +5,7 @@
     <p:sldMasterId id="2147483650" r:id="rId1"/>
   </p:sldMasterIdLst>
   <p:sldIdLst>
-    <p:sldId id="261" r:id="rId2"/>
-    <p:sldId id="262" r:id="rId3"/>
+    <p:sldId id="262" r:id="rId2"/>
   </p:sldIdLst>
   <p:sldSz cx="12192000" cy="6858000"/>
   <p:notesSz cx="7559675" cy="10691813"/>
@@ -14883,10 +14882,10 @@
       </p:grpSpPr>
       <p:sp>
         <p:nvSpPr>
-          <p:cNvPr id="6" name="Rectangle: Rounded Corners 5">
+          <p:cNvPr id="4" name="Rectangle 3">
             <a:extLst>
               <a:ext uri="{FF2B5EF4-FFF2-40B4-BE49-F238E27FC236}">
-                <a16:creationId xmlns:a16="http://schemas.microsoft.com/office/drawing/2014/main" id="{61B4FCAF-5A70-235A-3402-15B40340B63F}"/>
+                <a16:creationId xmlns:a16="http://schemas.microsoft.com/office/drawing/2014/main" id="{93188958-AAE3-44CE-8925-C1199477859F}"/>
               </a:ext>
             </a:extLst>
           </p:cNvPr>
@@ -14895,14 +14894,16 @@
         </p:nvSpPr>
         <p:spPr>
           <a:xfrm>
-            <a:off x="2801112" y="1641513"/>
-            <a:ext cx="1630680" cy="630936"/>
+            <a:off x="5024947" y="4290215"/>
+            <a:ext cx="1146103" cy="329943"/>
           </a:xfrm>
-          <a:prstGeom prst="roundRect">
+          <a:prstGeom prst="rect">
             <a:avLst/>
           </a:prstGeom>
-          <a:noFill/>
-          <a:ln>
+          <a:solidFill>
+            <a:schemeClr val="tx1"/>
+          </a:solidFill>
+          <a:ln w="19050">
             <a:solidFill>
               <a:schemeClr val="bg1"/>
             </a:solidFill>
@@ -14930,22 +14931,22 @@
           <a:p>
             <a:pPr algn="ctr"/>
             <a:r>
-              <a:rPr lang="en-US" sz="1400" dirty="0">
+              <a:rPr lang="en-US" sz="800" dirty="0">
                 <a:solidFill>
                   <a:schemeClr val="bg1"/>
                 </a:solidFill>
               </a:rPr>
-              <a:t>Model</a:t>
+              <a:t>state_eq.py</a:t>
             </a:r>
           </a:p>
         </p:txBody>
       </p:sp>
       <p:sp>
         <p:nvSpPr>
-          <p:cNvPr id="7" name="Rectangle: Rounded Corners 6">
+          <p:cNvPr id="5" name="Rectangle 4">
             <a:extLst>
               <a:ext uri="{FF2B5EF4-FFF2-40B4-BE49-F238E27FC236}">
-                <a16:creationId xmlns:a16="http://schemas.microsoft.com/office/drawing/2014/main" id="{6CAD3963-7C47-BEAD-424A-3F2E261B2320}"/>
+                <a16:creationId xmlns:a16="http://schemas.microsoft.com/office/drawing/2014/main" id="{1BBA56FC-4E4E-29A4-9860-5685CF427DC2}"/>
               </a:ext>
             </a:extLst>
           </p:cNvPr>
@@ -14954,14 +14955,16 @@
         </p:nvSpPr>
         <p:spPr>
           <a:xfrm>
-            <a:off x="2801112" y="2614764"/>
-            <a:ext cx="1630680" cy="630936"/>
+            <a:off x="3642429" y="4840160"/>
+            <a:ext cx="1146103" cy="329943"/>
           </a:xfrm>
-          <a:prstGeom prst="roundRect">
+          <a:prstGeom prst="rect">
             <a:avLst/>
           </a:prstGeom>
-          <a:noFill/>
-          <a:ln>
+          <a:solidFill>
+            <a:schemeClr val="tx1"/>
+          </a:solidFill>
+          <a:ln w="19050">
             <a:solidFill>
               <a:schemeClr val="bg1"/>
             </a:solidFill>
@@ -14989,22 +14992,22 @@
           <a:p>
             <a:pPr algn="ctr"/>
             <a:r>
-              <a:rPr lang="en-US" sz="1400" dirty="0">
+              <a:rPr lang="en-US" sz="800" dirty="0">
                 <a:solidFill>
                   <a:schemeClr val="bg1"/>
                 </a:solidFill>
               </a:rPr>
-              <a:t>Modules</a:t>
+              <a:t>kinetic_eq.py</a:t>
             </a:r>
           </a:p>
         </p:txBody>
       </p:sp>
       <p:sp>
         <p:nvSpPr>
-          <p:cNvPr id="8" name="Rectangle: Rounded Corners 7">
+          <p:cNvPr id="6" name="Rectangle 5">
             <a:extLst>
               <a:ext uri="{FF2B5EF4-FFF2-40B4-BE49-F238E27FC236}">
-                <a16:creationId xmlns:a16="http://schemas.microsoft.com/office/drawing/2014/main" id="{9D8FFA72-C0E2-78EF-41D8-4B2F74B3ABBB}"/>
+                <a16:creationId xmlns:a16="http://schemas.microsoft.com/office/drawing/2014/main" id="{3B799FCE-99FA-1364-7988-E86CACAA52E2}"/>
               </a:ext>
             </a:extLst>
           </p:cNvPr>
@@ -15013,14 +15016,16 @@
         </p:nvSpPr>
         <p:spPr>
           <a:xfrm>
-            <a:off x="2801112" y="3585654"/>
-            <a:ext cx="1630680" cy="630936"/>
+            <a:off x="5024947" y="4840160"/>
+            <a:ext cx="1146103" cy="329943"/>
           </a:xfrm>
-          <a:prstGeom prst="roundRect">
+          <a:prstGeom prst="rect">
             <a:avLst/>
           </a:prstGeom>
-          <a:noFill/>
-          <a:ln>
+          <a:solidFill>
+            <a:schemeClr val="tx1"/>
+          </a:solidFill>
+          <a:ln w="19050">
             <a:solidFill>
               <a:schemeClr val="bg1"/>
             </a:solidFill>
@@ -15048,22 +15053,22 @@
           <a:p>
             <a:pPr algn="ctr"/>
             <a:r>
-              <a:rPr lang="en-US" sz="1400" dirty="0">
+              <a:rPr lang="en-US" sz="800" dirty="0">
                 <a:solidFill>
                   <a:schemeClr val="bg1"/>
                 </a:solidFill>
               </a:rPr>
-              <a:t>Calibration</a:t>
+              <a:t>inst_value.py</a:t>
             </a:r>
           </a:p>
         </p:txBody>
       </p:sp>
       <p:sp>
         <p:nvSpPr>
-          <p:cNvPr id="9" name="Rectangle: Rounded Corners 8">
+          <p:cNvPr id="7" name="Rectangle 6">
             <a:extLst>
               <a:ext uri="{FF2B5EF4-FFF2-40B4-BE49-F238E27FC236}">
-                <a16:creationId xmlns:a16="http://schemas.microsoft.com/office/drawing/2014/main" id="{A824BFD7-2A20-0E72-54B9-EE1226FB7DE7}"/>
+                <a16:creationId xmlns:a16="http://schemas.microsoft.com/office/drawing/2014/main" id="{CDC07E90-E197-4BF1-E436-B3CBF2098582}"/>
               </a:ext>
             </a:extLst>
           </p:cNvPr>
@@ -15072,14 +15077,16 @@
         </p:nvSpPr>
         <p:spPr>
           <a:xfrm>
-            <a:off x="2801112" y="4558068"/>
-            <a:ext cx="1630680" cy="630936"/>
+            <a:off x="6407465" y="4840160"/>
+            <a:ext cx="1146103" cy="329943"/>
           </a:xfrm>
-          <a:prstGeom prst="roundRect">
+          <a:prstGeom prst="rect">
             <a:avLst/>
           </a:prstGeom>
-          <a:noFill/>
-          <a:ln>
+          <a:solidFill>
+            <a:schemeClr val="tx1"/>
+          </a:solidFill>
+          <a:ln w="19050">
             <a:solidFill>
               <a:schemeClr val="bg1"/>
             </a:solidFill>
@@ -15107,22 +15114,293 @@
           <a:p>
             <a:pPr algn="ctr"/>
             <a:r>
-              <a:rPr lang="en-US" sz="1400" dirty="0">
+              <a:rPr lang="en-US" sz="800" dirty="0">
                 <a:solidFill>
                   <a:schemeClr val="bg1"/>
                 </a:solidFill>
               </a:rPr>
-              <a:t>Data</a:t>
+              <a:t>coefficient.py</a:t>
             </a:r>
           </a:p>
         </p:txBody>
       </p:sp>
+      <p:cxnSp>
+        <p:nvCxnSpPr>
+          <p:cNvPr id="10" name="Connector: Elbow 9">
+            <a:extLst>
+              <a:ext uri="{FF2B5EF4-FFF2-40B4-BE49-F238E27FC236}">
+                <a16:creationId xmlns:a16="http://schemas.microsoft.com/office/drawing/2014/main" id="{57AD0A1C-0D13-8F5B-91B5-6BF5F81642A3}"/>
+              </a:ext>
+            </a:extLst>
+          </p:cNvPr>
+          <p:cNvCxnSpPr>
+            <a:stCxn id="5" idx="0"/>
+            <a:endCxn id="4" idx="1"/>
+          </p:cNvCxnSpPr>
+          <p:nvPr/>
+        </p:nvCxnSpPr>
+        <p:spPr>
+          <a:xfrm rot="5400000" flipH="1" flipV="1">
+            <a:off x="4427728" y="4242941"/>
+            <a:ext cx="384973" cy="809466"/>
+          </a:xfrm>
+          <a:prstGeom prst="bentConnector2">
+            <a:avLst/>
+          </a:prstGeom>
+          <a:ln w="19050">
+            <a:solidFill>
+              <a:schemeClr val="bg1"/>
+            </a:solidFill>
+            <a:tailEnd type="triangle"/>
+          </a:ln>
+        </p:spPr>
+        <p:style>
+          <a:lnRef idx="1">
+            <a:schemeClr val="accent1"/>
+          </a:lnRef>
+          <a:fillRef idx="0">
+            <a:schemeClr val="accent1"/>
+          </a:fillRef>
+          <a:effectRef idx="0">
+            <a:schemeClr val="accent1"/>
+          </a:effectRef>
+          <a:fontRef idx="minor">
+            <a:schemeClr val="tx1"/>
+          </a:fontRef>
+        </p:style>
+      </p:cxnSp>
+      <p:cxnSp>
+        <p:nvCxnSpPr>
+          <p:cNvPr id="11" name="Connector: Elbow 10">
+            <a:extLst>
+              <a:ext uri="{FF2B5EF4-FFF2-40B4-BE49-F238E27FC236}">
+                <a16:creationId xmlns:a16="http://schemas.microsoft.com/office/drawing/2014/main" id="{CB48BE70-926C-0721-7A39-CBEFE49CBEF9}"/>
+              </a:ext>
+            </a:extLst>
+          </p:cNvPr>
+          <p:cNvCxnSpPr>
+            <a:cxnSpLocks/>
+            <a:stCxn id="7" idx="0"/>
+            <a:endCxn id="4" idx="3"/>
+          </p:cNvCxnSpPr>
+          <p:nvPr/>
+        </p:nvCxnSpPr>
+        <p:spPr>
+          <a:xfrm rot="16200000" flipV="1">
+            <a:off x="6383298" y="4242940"/>
+            <a:ext cx="384973" cy="809467"/>
+          </a:xfrm>
+          <a:prstGeom prst="bentConnector2">
+            <a:avLst/>
+          </a:prstGeom>
+          <a:ln w="19050">
+            <a:solidFill>
+              <a:schemeClr val="bg1"/>
+            </a:solidFill>
+            <a:tailEnd type="triangle"/>
+          </a:ln>
+        </p:spPr>
+        <p:style>
+          <a:lnRef idx="1">
+            <a:schemeClr val="accent1"/>
+          </a:lnRef>
+          <a:fillRef idx="0">
+            <a:schemeClr val="accent1"/>
+          </a:fillRef>
+          <a:effectRef idx="0">
+            <a:schemeClr val="accent1"/>
+          </a:effectRef>
+          <a:fontRef idx="minor">
+            <a:schemeClr val="tx1"/>
+          </a:fontRef>
+        </p:style>
+      </p:cxnSp>
+      <p:cxnSp>
+        <p:nvCxnSpPr>
+          <p:cNvPr id="15" name="Straight Arrow Connector 14">
+            <a:extLst>
+              <a:ext uri="{FF2B5EF4-FFF2-40B4-BE49-F238E27FC236}">
+                <a16:creationId xmlns:a16="http://schemas.microsoft.com/office/drawing/2014/main" id="{3C4A7473-F79D-67B3-1CDE-6E21BAA6277E}"/>
+              </a:ext>
+            </a:extLst>
+          </p:cNvPr>
+          <p:cNvCxnSpPr>
+            <a:stCxn id="6" idx="0"/>
+            <a:endCxn id="4" idx="2"/>
+          </p:cNvCxnSpPr>
+          <p:nvPr/>
+        </p:nvCxnSpPr>
+        <p:spPr>
+          <a:xfrm flipV="1">
+            <a:off x="5597999" y="4620158"/>
+            <a:ext cx="0" cy="220002"/>
+          </a:xfrm>
+          <a:prstGeom prst="straightConnector1">
+            <a:avLst/>
+          </a:prstGeom>
+          <a:ln w="19050">
+            <a:solidFill>
+              <a:schemeClr val="bg1"/>
+            </a:solidFill>
+            <a:tailEnd type="triangle"/>
+          </a:ln>
+        </p:spPr>
+        <p:style>
+          <a:lnRef idx="1">
+            <a:schemeClr val="accent1"/>
+          </a:lnRef>
+          <a:fillRef idx="0">
+            <a:schemeClr val="accent1"/>
+          </a:fillRef>
+          <a:effectRef idx="0">
+            <a:schemeClr val="accent1"/>
+          </a:effectRef>
+          <a:fontRef idx="minor">
+            <a:schemeClr val="tx1"/>
+          </a:fontRef>
+        </p:style>
+      </p:cxnSp>
+      <p:cxnSp>
+        <p:nvCxnSpPr>
+          <p:cNvPr id="17" name="Straight Arrow Connector 16">
+            <a:extLst>
+              <a:ext uri="{FF2B5EF4-FFF2-40B4-BE49-F238E27FC236}">
+                <a16:creationId xmlns:a16="http://schemas.microsoft.com/office/drawing/2014/main" id="{D7ECB6B8-47F5-9CB5-3170-71C90B93D15D}"/>
+              </a:ext>
+            </a:extLst>
+          </p:cNvPr>
+          <p:cNvCxnSpPr>
+            <a:cxnSpLocks/>
+          </p:cNvCxnSpPr>
+          <p:nvPr/>
+        </p:nvCxnSpPr>
+        <p:spPr>
+          <a:xfrm>
+            <a:off x="5958397" y="3502560"/>
+            <a:ext cx="914400" cy="914400"/>
+          </a:xfrm>
+          <a:prstGeom prst="straightConnector1">
+            <a:avLst/>
+          </a:prstGeom>
+          <a:ln>
+            <a:tailEnd type="triangle"/>
+          </a:ln>
+        </p:spPr>
+        <p:style>
+          <a:lnRef idx="1">
+            <a:schemeClr val="accent1"/>
+          </a:lnRef>
+          <a:fillRef idx="0">
+            <a:schemeClr val="accent1"/>
+          </a:fillRef>
+          <a:effectRef idx="0">
+            <a:schemeClr val="accent1"/>
+          </a:effectRef>
+          <a:fontRef idx="minor">
+            <a:schemeClr val="tx1"/>
+          </a:fontRef>
+        </p:style>
+      </p:cxnSp>
+      <p:cxnSp>
+        <p:nvCxnSpPr>
+          <p:cNvPr id="20" name="Straight Arrow Connector 19">
+            <a:extLst>
+              <a:ext uri="{FF2B5EF4-FFF2-40B4-BE49-F238E27FC236}">
+                <a16:creationId xmlns:a16="http://schemas.microsoft.com/office/drawing/2014/main" id="{E8BF0B7F-FD6F-07D7-0EC3-F7D1A48FDFBA}"/>
+              </a:ext>
+            </a:extLst>
+          </p:cNvPr>
+          <p:cNvCxnSpPr>
+            <a:cxnSpLocks/>
+            <a:stCxn id="7" idx="1"/>
+            <a:endCxn id="6" idx="3"/>
+          </p:cNvCxnSpPr>
+          <p:nvPr/>
+        </p:nvCxnSpPr>
+        <p:spPr>
+          <a:xfrm flipH="1">
+            <a:off x="6171050" y="5005132"/>
+            <a:ext cx="236415" cy="0"/>
+          </a:xfrm>
+          <a:prstGeom prst="straightConnector1">
+            <a:avLst/>
+          </a:prstGeom>
+          <a:ln w="19050">
+            <a:solidFill>
+              <a:schemeClr val="bg1"/>
+            </a:solidFill>
+            <a:tailEnd type="triangle"/>
+          </a:ln>
+        </p:spPr>
+        <p:style>
+          <a:lnRef idx="1">
+            <a:schemeClr val="accent1"/>
+          </a:lnRef>
+          <a:fillRef idx="0">
+            <a:schemeClr val="accent1"/>
+          </a:fillRef>
+          <a:effectRef idx="0">
+            <a:schemeClr val="accent1"/>
+          </a:effectRef>
+          <a:fontRef idx="minor">
+            <a:schemeClr val="tx1"/>
+          </a:fontRef>
+        </p:style>
+      </p:cxnSp>
+      <p:cxnSp>
+        <p:nvCxnSpPr>
+          <p:cNvPr id="23" name="Connector: Elbow 22">
+            <a:extLst>
+              <a:ext uri="{FF2B5EF4-FFF2-40B4-BE49-F238E27FC236}">
+                <a16:creationId xmlns:a16="http://schemas.microsoft.com/office/drawing/2014/main" id="{350DE003-68ED-4C2B-D146-5AFFFC76803F}"/>
+              </a:ext>
+            </a:extLst>
+          </p:cNvPr>
+          <p:cNvCxnSpPr>
+            <a:cxnSpLocks/>
+            <a:stCxn id="7" idx="2"/>
+            <a:endCxn id="5" idx="2"/>
+          </p:cNvCxnSpPr>
+          <p:nvPr/>
+        </p:nvCxnSpPr>
+        <p:spPr>
+          <a:xfrm rot="5400000">
+            <a:off x="5597999" y="3787585"/>
+            <a:ext cx="12700" cy="2765036"/>
+          </a:xfrm>
+          <a:prstGeom prst="bentConnector3">
+            <a:avLst>
+              <a:gd name="adj1" fmla="val 1800000"/>
+            </a:avLst>
+          </a:prstGeom>
+          <a:ln w="19050">
+            <a:solidFill>
+              <a:schemeClr val="bg1"/>
+            </a:solidFill>
+            <a:tailEnd type="triangle"/>
+          </a:ln>
+        </p:spPr>
+        <p:style>
+          <a:lnRef idx="1">
+            <a:schemeClr val="accent1"/>
+          </a:lnRef>
+          <a:fillRef idx="0">
+            <a:schemeClr val="accent1"/>
+          </a:fillRef>
+          <a:effectRef idx="0">
+            <a:schemeClr val="accent1"/>
+          </a:effectRef>
+          <a:fontRef idx="minor">
+            <a:schemeClr val="tx1"/>
+          </a:fontRef>
+        </p:style>
+      </p:cxnSp>
       <p:sp>
         <p:nvSpPr>
-          <p:cNvPr id="10" name="Oval 9">
+          <p:cNvPr id="27" name="Rectangle 26">
             <a:extLst>
               <a:ext uri="{FF2B5EF4-FFF2-40B4-BE49-F238E27FC236}">
-                <a16:creationId xmlns:a16="http://schemas.microsoft.com/office/drawing/2014/main" id="{5FA9CB45-CF11-A75F-C5EC-C5C27E002163}"/>
+                <a16:creationId xmlns:a16="http://schemas.microsoft.com/office/drawing/2014/main" id="{B63954C3-92F5-D357-48E0-1F727B7E3E63}"/>
               </a:ext>
             </a:extLst>
           </p:cNvPr>
@@ -15131,14 +15409,16 @@
         </p:nvSpPr>
         <p:spPr>
           <a:xfrm>
-            <a:off x="941832" y="2968752"/>
-            <a:ext cx="900000" cy="900000"/>
+            <a:off x="5024947" y="3637708"/>
+            <a:ext cx="1146103" cy="428367"/>
           </a:xfrm>
-          <a:prstGeom prst="ellipse">
+          <a:prstGeom prst="rect">
             <a:avLst/>
           </a:prstGeom>
-          <a:noFill/>
-          <a:ln w="28575">
+          <a:solidFill>
+            <a:schemeClr val="tx1"/>
+          </a:solidFill>
+          <a:ln w="19050">
             <a:solidFill>
               <a:schemeClr val="bg1"/>
             </a:solidFill>
@@ -15166,220 +15446,38 @@
           <a:p>
             <a:pPr algn="ctr"/>
             <a:r>
-              <a:rPr lang="en-US" sz="1600" dirty="0">
+              <a:rPr lang="en-US" sz="800" dirty="0">
                 <a:solidFill>
                   <a:schemeClr val="bg1"/>
                 </a:solidFill>
               </a:rPr>
-              <a:t>Root</a:t>
+              <a:t>model.py</a:t>
             </a:r>
           </a:p>
           <a:p>
             <a:pPr algn="ctr"/>
-            <a:r>
-              <a:rPr lang="en-US" sz="1600" dirty="0">
-                <a:solidFill>
-                  <a:schemeClr val="bg1"/>
-                </a:solidFill>
-              </a:rPr>
-              <a:t>path</a:t>
-            </a:r>
+            <a:endParaRPr lang="en-US" sz="800" dirty="0">
+              <a:solidFill>
+                <a:schemeClr val="bg1"/>
+              </a:solidFill>
+            </a:endParaRPr>
+          </a:p>
+          <a:p>
+            <a:pPr algn="ctr"/>
+            <a:endParaRPr lang="en-US" sz="800" dirty="0">
+              <a:solidFill>
+                <a:schemeClr val="bg1"/>
+              </a:solidFill>
+            </a:endParaRPr>
           </a:p>
         </p:txBody>
       </p:sp>
-      <p:cxnSp>
-        <p:nvCxnSpPr>
-          <p:cNvPr id="12" name="Connector: Elbow 11">
+      <p:sp>
+        <p:nvSpPr>
+          <p:cNvPr id="28" name="Rectangle 27">
             <a:extLst>
               <a:ext uri="{FF2B5EF4-FFF2-40B4-BE49-F238E27FC236}">
-                <a16:creationId xmlns:a16="http://schemas.microsoft.com/office/drawing/2014/main" id="{76EDB7C5-8662-0880-6470-A5435337556C}"/>
-              </a:ext>
-            </a:extLst>
-          </p:cNvPr>
-          <p:cNvCxnSpPr>
-            <a:stCxn id="10" idx="0"/>
-            <a:endCxn id="6" idx="1"/>
-          </p:cNvCxnSpPr>
-          <p:nvPr/>
-        </p:nvCxnSpPr>
-        <p:spPr>
-          <a:xfrm rot="5400000" flipH="1" flipV="1">
-            <a:off x="1590587" y="1758227"/>
-            <a:ext cx="1011771" cy="1409280"/>
-          </a:xfrm>
-          <a:prstGeom prst="bentConnector2">
-            <a:avLst/>
-          </a:prstGeom>
-          <a:ln>
-            <a:solidFill>
-              <a:schemeClr val="bg1"/>
-            </a:solidFill>
-            <a:headEnd type="oval" w="med" len="med"/>
-            <a:tailEnd type="oval" w="med" len="med"/>
-          </a:ln>
-        </p:spPr>
-        <p:style>
-          <a:lnRef idx="1">
-            <a:schemeClr val="accent1"/>
-          </a:lnRef>
-          <a:fillRef idx="0">
-            <a:schemeClr val="accent1"/>
-          </a:fillRef>
-          <a:effectRef idx="0">
-            <a:schemeClr val="accent1"/>
-          </a:effectRef>
-          <a:fontRef idx="minor">
-            <a:schemeClr val="tx1"/>
-          </a:fontRef>
-        </p:style>
-      </p:cxnSp>
-      <p:cxnSp>
-        <p:nvCxnSpPr>
-          <p:cNvPr id="13" name="Connector: Elbow 12">
-            <a:extLst>
-              <a:ext uri="{FF2B5EF4-FFF2-40B4-BE49-F238E27FC236}">
-                <a16:creationId xmlns:a16="http://schemas.microsoft.com/office/drawing/2014/main" id="{507808C0-29B0-2C5B-8BBC-39597A96A24E}"/>
-              </a:ext>
-            </a:extLst>
-          </p:cNvPr>
-          <p:cNvCxnSpPr>
-            <a:cxnSpLocks/>
-            <a:stCxn id="10" idx="7"/>
-            <a:endCxn id="7" idx="1"/>
-          </p:cNvCxnSpPr>
-          <p:nvPr/>
-        </p:nvCxnSpPr>
-        <p:spPr>
-          <a:xfrm rot="5400000" flipH="1" flipV="1">
-            <a:off x="2170410" y="2469852"/>
-            <a:ext cx="170322" cy="1091082"/>
-          </a:xfrm>
-          <a:prstGeom prst="bentConnector2">
-            <a:avLst/>
-          </a:prstGeom>
-          <a:ln>
-            <a:solidFill>
-              <a:schemeClr val="bg1"/>
-            </a:solidFill>
-            <a:headEnd type="oval" w="med" len="med"/>
-            <a:tailEnd type="oval" w="med" len="med"/>
-          </a:ln>
-        </p:spPr>
-        <p:style>
-          <a:lnRef idx="1">
-            <a:schemeClr val="accent1"/>
-          </a:lnRef>
-          <a:fillRef idx="0">
-            <a:schemeClr val="accent1"/>
-          </a:fillRef>
-          <a:effectRef idx="0">
-            <a:schemeClr val="accent1"/>
-          </a:effectRef>
-          <a:fontRef idx="minor">
-            <a:schemeClr val="tx1"/>
-          </a:fontRef>
-        </p:style>
-      </p:cxnSp>
-      <p:cxnSp>
-        <p:nvCxnSpPr>
-          <p:cNvPr id="16" name="Connector: Elbow 15">
-            <a:extLst>
-              <a:ext uri="{FF2B5EF4-FFF2-40B4-BE49-F238E27FC236}">
-                <a16:creationId xmlns:a16="http://schemas.microsoft.com/office/drawing/2014/main" id="{1C07D2EE-7DDB-D2A1-2DFC-659899AF34B4}"/>
-              </a:ext>
-            </a:extLst>
-          </p:cNvPr>
-          <p:cNvCxnSpPr>
-            <a:cxnSpLocks/>
-            <a:stCxn id="10" idx="5"/>
-            <a:endCxn id="8" idx="1"/>
-          </p:cNvCxnSpPr>
-          <p:nvPr/>
-        </p:nvCxnSpPr>
-        <p:spPr>
-          <a:xfrm rot="16200000" flipH="1">
-            <a:off x="2173485" y="3273495"/>
-            <a:ext cx="164172" cy="1091082"/>
-          </a:xfrm>
-          <a:prstGeom prst="bentConnector2">
-            <a:avLst/>
-          </a:prstGeom>
-          <a:ln>
-            <a:solidFill>
-              <a:schemeClr val="bg1"/>
-            </a:solidFill>
-            <a:headEnd type="oval" w="med" len="med"/>
-            <a:tailEnd type="oval" w="med" len="med"/>
-          </a:ln>
-        </p:spPr>
-        <p:style>
-          <a:lnRef idx="1">
-            <a:schemeClr val="accent1"/>
-          </a:lnRef>
-          <a:fillRef idx="0">
-            <a:schemeClr val="accent1"/>
-          </a:fillRef>
-          <a:effectRef idx="0">
-            <a:schemeClr val="accent1"/>
-          </a:effectRef>
-          <a:fontRef idx="minor">
-            <a:schemeClr val="tx1"/>
-          </a:fontRef>
-        </p:style>
-      </p:cxnSp>
-      <p:cxnSp>
-        <p:nvCxnSpPr>
-          <p:cNvPr id="23" name="Connector: Elbow 22">
-            <a:extLst>
-              <a:ext uri="{FF2B5EF4-FFF2-40B4-BE49-F238E27FC236}">
-                <a16:creationId xmlns:a16="http://schemas.microsoft.com/office/drawing/2014/main" id="{ADBC15C5-1B76-B923-F6F7-C617D8C71C73}"/>
-              </a:ext>
-            </a:extLst>
-          </p:cNvPr>
-          <p:cNvCxnSpPr>
-            <a:cxnSpLocks/>
-            <a:stCxn id="10" idx="4"/>
-            <a:endCxn id="9" idx="1"/>
-          </p:cNvCxnSpPr>
-          <p:nvPr/>
-        </p:nvCxnSpPr>
-        <p:spPr>
-          <a:xfrm rot="16200000" flipH="1">
-            <a:off x="1594080" y="3666504"/>
-            <a:ext cx="1004784" cy="1409280"/>
-          </a:xfrm>
-          <a:prstGeom prst="bentConnector2">
-            <a:avLst/>
-          </a:prstGeom>
-          <a:ln>
-            <a:solidFill>
-              <a:schemeClr val="bg1"/>
-            </a:solidFill>
-            <a:headEnd type="oval" w="med" len="med"/>
-            <a:tailEnd type="oval" w="med" len="med"/>
-          </a:ln>
-        </p:spPr>
-        <p:style>
-          <a:lnRef idx="1">
-            <a:schemeClr val="accent1"/>
-          </a:lnRef>
-          <a:fillRef idx="0">
-            <a:schemeClr val="accent1"/>
-          </a:fillRef>
-          <a:effectRef idx="0">
-            <a:schemeClr val="accent1"/>
-          </a:effectRef>
-          <a:fontRef idx="minor">
-            <a:schemeClr val="tx1"/>
-          </a:fontRef>
-        </p:style>
-      </p:cxnSp>
-      <p:sp>
-        <p:nvSpPr>
-          <p:cNvPr id="32" name="Rectangle: Rounded Corners 31">
-            <a:extLst>
-              <a:ext uri="{FF2B5EF4-FFF2-40B4-BE49-F238E27FC236}">
-                <a16:creationId xmlns:a16="http://schemas.microsoft.com/office/drawing/2014/main" id="{34F8EC7D-CCB9-2AD9-59C9-ED3AF8BD4E66}"/>
+                <a16:creationId xmlns:a16="http://schemas.microsoft.com/office/drawing/2014/main" id="{6E865BF1-3326-0F3D-56C5-3210A67B88DD}"/>
               </a:ext>
             </a:extLst>
           </p:cNvPr>
@@ -15388,14 +15486,16 @@
         </p:nvSpPr>
         <p:spPr>
           <a:xfrm>
-            <a:off x="6760468" y="1641513"/>
-            <a:ext cx="1630680" cy="630936"/>
+            <a:off x="5024947" y="3796328"/>
+            <a:ext cx="1146103" cy="287273"/>
           </a:xfrm>
-          <a:prstGeom prst="roundRect">
+          <a:prstGeom prst="rect">
             <a:avLst/>
           </a:prstGeom>
-          <a:noFill/>
-          <a:ln>
+          <a:solidFill>
+            <a:schemeClr val="tx2"/>
+          </a:solidFill>
+          <a:ln w="19050">
             <a:solidFill>
               <a:schemeClr val="bg1"/>
             </a:solidFill>
@@ -15423,22 +15523,68 @@
           <a:p>
             <a:pPr algn="ctr"/>
             <a:r>
-              <a:rPr lang="en-US" sz="1400" dirty="0">
+              <a:rPr lang="en-US" sz="800" dirty="0">
                 <a:solidFill>
                   <a:schemeClr val="bg1"/>
                 </a:solidFill>
               </a:rPr>
-              <a:t>States equations</a:t>
+              <a:t>Class: PEMFC</a:t>
             </a:r>
           </a:p>
         </p:txBody>
       </p:sp>
+      <p:cxnSp>
+        <p:nvCxnSpPr>
+          <p:cNvPr id="30" name="Straight Arrow Connector 29">
+            <a:extLst>
+              <a:ext uri="{FF2B5EF4-FFF2-40B4-BE49-F238E27FC236}">
+                <a16:creationId xmlns:a16="http://schemas.microsoft.com/office/drawing/2014/main" id="{2392A148-F25D-3B13-CE6D-30CFB454FBE7}"/>
+              </a:ext>
+            </a:extLst>
+          </p:cNvPr>
+          <p:cNvCxnSpPr>
+            <a:cxnSpLocks/>
+            <a:stCxn id="4" idx="0"/>
+            <a:endCxn id="28" idx="2"/>
+          </p:cNvCxnSpPr>
+          <p:nvPr/>
+        </p:nvCxnSpPr>
+        <p:spPr>
+          <a:xfrm flipV="1">
+            <a:off x="5597999" y="4083601"/>
+            <a:ext cx="0" cy="206614"/>
+          </a:xfrm>
+          <a:prstGeom prst="straightConnector1">
+            <a:avLst/>
+          </a:prstGeom>
+          <a:ln w="19050">
+            <a:solidFill>
+              <a:schemeClr val="bg1"/>
+            </a:solidFill>
+            <a:tailEnd type="triangle"/>
+          </a:ln>
+        </p:spPr>
+        <p:style>
+          <a:lnRef idx="1">
+            <a:schemeClr val="accent1"/>
+          </a:lnRef>
+          <a:fillRef idx="0">
+            <a:schemeClr val="accent1"/>
+          </a:fillRef>
+          <a:effectRef idx="0">
+            <a:schemeClr val="accent1"/>
+          </a:effectRef>
+          <a:fontRef idx="minor">
+            <a:schemeClr val="tx1"/>
+          </a:fontRef>
+        </p:style>
+      </p:cxnSp>
       <p:sp>
         <p:nvSpPr>
-          <p:cNvPr id="33" name="Rectangle: Rounded Corners 32">
+          <p:cNvPr id="13" name="Rectangle 12">
             <a:extLst>
               <a:ext uri="{FF2B5EF4-FFF2-40B4-BE49-F238E27FC236}">
-                <a16:creationId xmlns:a16="http://schemas.microsoft.com/office/drawing/2014/main" id="{1F598A59-F452-BFF0-B512-E518E12C5681}"/>
+                <a16:creationId xmlns:a16="http://schemas.microsoft.com/office/drawing/2014/main" id="{21385016-B1F9-C491-FCE7-9BE8D2F8E69F}"/>
               </a:ext>
             </a:extLst>
           </p:cNvPr>
@@ -15447,16 +15593,18 @@
         </p:nvSpPr>
         <p:spPr>
           <a:xfrm>
-            <a:off x="8740146" y="1641513"/>
-            <a:ext cx="1630680" cy="630936"/>
+            <a:off x="5024020" y="1653929"/>
+            <a:ext cx="1146103" cy="329943"/>
           </a:xfrm>
-          <a:prstGeom prst="roundRect">
+          <a:prstGeom prst="rect">
             <a:avLst/>
           </a:prstGeom>
-          <a:noFill/>
-          <a:ln>
+          <a:solidFill>
+            <a:schemeClr val="tx1"/>
+          </a:solidFill>
+          <a:ln w="19050">
             <a:solidFill>
-              <a:schemeClr val="bg1"/>
+              <a:srgbClr val="29BD2D"/>
             </a:solidFill>
           </a:ln>
         </p:spPr>
@@ -15482,22 +15630,68 @@
           <a:p>
             <a:pPr algn="ctr"/>
             <a:r>
-              <a:rPr lang="en-US" sz="1400" dirty="0">
+              <a:rPr lang="en-US" sz="800" dirty="0">
                 <a:solidFill>
                   <a:schemeClr val="bg1"/>
                 </a:solidFill>
               </a:rPr>
-              <a:t>Physics laws</a:t>
+              <a:t>main.py</a:t>
             </a:r>
           </a:p>
         </p:txBody>
       </p:sp>
+      <p:cxnSp>
+        <p:nvCxnSpPr>
+          <p:cNvPr id="14" name="Straight Arrow Connector 13">
+            <a:extLst>
+              <a:ext uri="{FF2B5EF4-FFF2-40B4-BE49-F238E27FC236}">
+                <a16:creationId xmlns:a16="http://schemas.microsoft.com/office/drawing/2014/main" id="{1626DE21-66F6-0868-60FC-F50D8C4BB79E}"/>
+              </a:ext>
+            </a:extLst>
+          </p:cNvPr>
+          <p:cNvCxnSpPr>
+            <a:cxnSpLocks/>
+            <a:stCxn id="27" idx="0"/>
+            <a:endCxn id="13" idx="2"/>
+          </p:cNvCxnSpPr>
+          <p:nvPr/>
+        </p:nvCxnSpPr>
+        <p:spPr>
+          <a:xfrm flipH="1" flipV="1">
+            <a:off x="5597072" y="1983872"/>
+            <a:ext cx="927" cy="1653836"/>
+          </a:xfrm>
+          <a:prstGeom prst="straightConnector1">
+            <a:avLst/>
+          </a:prstGeom>
+          <a:ln w="19050">
+            <a:solidFill>
+              <a:schemeClr val="bg1"/>
+            </a:solidFill>
+            <a:tailEnd type="triangle"/>
+          </a:ln>
+        </p:spPr>
+        <p:style>
+          <a:lnRef idx="1">
+            <a:schemeClr val="accent1"/>
+          </a:lnRef>
+          <a:fillRef idx="0">
+            <a:schemeClr val="accent1"/>
+          </a:fillRef>
+          <a:effectRef idx="0">
+            <a:schemeClr val="accent1"/>
+          </a:effectRef>
+          <a:fontRef idx="minor">
+            <a:schemeClr val="tx1"/>
+          </a:fontRef>
+        </p:style>
+      </p:cxnSp>
       <p:sp>
         <p:nvSpPr>
-          <p:cNvPr id="34" name="Rectangle: Rounded Corners 33">
+          <p:cNvPr id="24" name="Rectangle: Rounded Corners 23">
             <a:extLst>
               <a:ext uri="{FF2B5EF4-FFF2-40B4-BE49-F238E27FC236}">
-                <a16:creationId xmlns:a16="http://schemas.microsoft.com/office/drawing/2014/main" id="{8C9169A2-8331-3195-725F-DA1C4BB4ABA1}"/>
+                <a16:creationId xmlns:a16="http://schemas.microsoft.com/office/drawing/2014/main" id="{C3CB8AC4-8386-494B-59B7-183B15AE4C47}"/>
               </a:ext>
             </a:extLst>
           </p:cNvPr>
@@ -15506,16 +15700,210 @@
         </p:nvSpPr>
         <p:spPr>
           <a:xfrm>
-            <a:off x="4780790" y="1641513"/>
-            <a:ext cx="1630680" cy="630936"/>
+            <a:off x="3283323" y="3473469"/>
+            <a:ext cx="4613415" cy="2210100"/>
           </a:xfrm>
           <a:prstGeom prst="roundRect">
+            <a:avLst>
+              <a:gd name="adj" fmla="val 7782"/>
+            </a:avLst>
+          </a:prstGeom>
+          <a:noFill/>
+          <a:ln w="9525" cap="flat" cmpd="sng" algn="ctr">
+            <a:solidFill>
+              <a:schemeClr val="dk1"/>
+            </a:solidFill>
+            <a:prstDash val="dash"/>
+            <a:round/>
+            <a:headEnd type="none" w="med" len="med"/>
+            <a:tailEnd type="none" w="med" len="med"/>
+          </a:ln>
+        </p:spPr>
+        <p:style>
+          <a:lnRef idx="0">
+            <a:scrgbClr r="0" g="0" b="0"/>
+          </a:lnRef>
+          <a:fillRef idx="0">
+            <a:scrgbClr r="0" g="0" b="0"/>
+          </a:fillRef>
+          <a:effectRef idx="0">
+            <a:scrgbClr r="0" g="0" b="0"/>
+          </a:effectRef>
+          <a:fontRef idx="minor">
+            <a:schemeClr val="dk1"/>
+          </a:fontRef>
+        </p:style>
+        <p:txBody>
+          <a:bodyPr rtlCol="0" anchor="ctr"/>
+          <a:lstStyle/>
+          <a:p>
+            <a:pPr algn="ctr"/>
+            <a:endParaRPr lang="en-US" dirty="0"/>
+          </a:p>
+        </p:txBody>
+      </p:sp>
+      <p:sp>
+        <p:nvSpPr>
+          <p:cNvPr id="25" name="Rectangle: Rounded Corners 24">
+            <a:extLst>
+              <a:ext uri="{FF2B5EF4-FFF2-40B4-BE49-F238E27FC236}">
+                <a16:creationId xmlns:a16="http://schemas.microsoft.com/office/drawing/2014/main" id="{1BB960B8-A4DE-975E-84C2-E865A0BF710D}"/>
+              </a:ext>
+            </a:extLst>
+          </p:cNvPr>
+          <p:cNvSpPr/>
+          <p:nvPr/>
+        </p:nvSpPr>
+        <p:spPr>
+          <a:xfrm>
+            <a:off x="6348095" y="1907248"/>
+            <a:ext cx="1559859" cy="1285614"/>
+          </a:xfrm>
+          <a:prstGeom prst="roundRect">
+            <a:avLst>
+              <a:gd name="adj" fmla="val 7782"/>
+            </a:avLst>
+          </a:prstGeom>
+          <a:noFill/>
+          <a:ln w="9525" cap="flat" cmpd="sng" algn="ctr">
+            <a:solidFill>
+              <a:schemeClr val="dk1"/>
+            </a:solidFill>
+            <a:prstDash val="dash"/>
+            <a:round/>
+            <a:headEnd type="none" w="med" len="med"/>
+            <a:tailEnd type="none" w="med" len="med"/>
+          </a:ln>
+        </p:spPr>
+        <p:style>
+          <a:lnRef idx="0">
+            <a:scrgbClr r="0" g="0" b="0"/>
+          </a:lnRef>
+          <a:fillRef idx="0">
+            <a:scrgbClr r="0" g="0" b="0"/>
+          </a:fillRef>
+          <a:effectRef idx="0">
+            <a:scrgbClr r="0" g="0" b="0"/>
+          </a:effectRef>
+          <a:fontRef idx="minor">
+            <a:schemeClr val="dk1"/>
+          </a:fontRef>
+        </p:style>
+        <p:txBody>
+          <a:bodyPr rtlCol="0" anchor="ctr"/>
+          <a:lstStyle/>
+          <a:p>
+            <a:pPr algn="ctr"/>
+            <a:endParaRPr lang="en-US"/>
+          </a:p>
+        </p:txBody>
+      </p:sp>
+      <p:sp>
+        <p:nvSpPr>
+          <p:cNvPr id="29" name="TextBox 28">
+            <a:extLst>
+              <a:ext uri="{FF2B5EF4-FFF2-40B4-BE49-F238E27FC236}">
+                <a16:creationId xmlns:a16="http://schemas.microsoft.com/office/drawing/2014/main" id="{BA85DF0B-56C5-434E-5BC7-0F904D294EF8}"/>
+              </a:ext>
+            </a:extLst>
+          </p:cNvPr>
+          <p:cNvSpPr txBox="1"/>
+          <p:nvPr/>
+        </p:nvSpPr>
+        <p:spPr>
+          <a:xfrm>
+            <a:off x="5253991" y="5406570"/>
+            <a:ext cx="688009" cy="276999"/>
+          </a:xfrm>
+          <a:prstGeom prst="rect">
             <a:avLst/>
           </a:prstGeom>
           <a:noFill/>
-          <a:ln>
+        </p:spPr>
+        <p:txBody>
+          <a:bodyPr wrap="none" rtlCol="0">
+            <a:spAutoFit/>
+          </a:bodyPr>
+          <a:lstStyle/>
+          <a:p>
+            <a:pPr algn="ctr"/>
+            <a:r>
+              <a:rPr lang="en-US" sz="1200" dirty="0">
+                <a:solidFill>
+                  <a:schemeClr val="bg1"/>
+                </a:solidFill>
+              </a:rPr>
+              <a:t>./model</a:t>
+            </a:r>
+          </a:p>
+        </p:txBody>
+      </p:sp>
+      <p:sp>
+        <p:nvSpPr>
+          <p:cNvPr id="31" name="TextBox 30">
+            <a:extLst>
+              <a:ext uri="{FF2B5EF4-FFF2-40B4-BE49-F238E27FC236}">
+                <a16:creationId xmlns:a16="http://schemas.microsoft.com/office/drawing/2014/main" id="{5A0B6823-77C5-C8FF-DDF3-F9B41522C90E}"/>
+              </a:ext>
+            </a:extLst>
+          </p:cNvPr>
+          <p:cNvSpPr txBox="1"/>
+          <p:nvPr/>
+        </p:nvSpPr>
+        <p:spPr>
+          <a:xfrm>
+            <a:off x="6789455" y="2991468"/>
+            <a:ext cx="595035" cy="246221"/>
+          </a:xfrm>
+          <a:prstGeom prst="rect">
+            <a:avLst/>
+          </a:prstGeom>
+          <a:noFill/>
+        </p:spPr>
+        <p:txBody>
+          <a:bodyPr wrap="none" rtlCol="0">
+            <a:spAutoFit/>
+          </a:bodyPr>
+          <a:lstStyle/>
+          <a:p>
+            <a:pPr algn="ctr"/>
+            <a:r>
+              <a:rPr lang="en-US" sz="1000" dirty="0">
+                <a:solidFill>
+                  <a:schemeClr val="bg1"/>
+                </a:solidFill>
+              </a:rPr>
+              <a:t>./config</a:t>
+            </a:r>
+          </a:p>
+        </p:txBody>
+      </p:sp>
+      <p:sp>
+        <p:nvSpPr>
+          <p:cNvPr id="32" name="Rectangle 31">
+            <a:extLst>
+              <a:ext uri="{FF2B5EF4-FFF2-40B4-BE49-F238E27FC236}">
+                <a16:creationId xmlns:a16="http://schemas.microsoft.com/office/drawing/2014/main" id="{E46E9CC4-1D32-1569-FE57-9935AACC3C55}"/>
+              </a:ext>
+            </a:extLst>
+          </p:cNvPr>
+          <p:cNvSpPr/>
+          <p:nvPr/>
+        </p:nvSpPr>
+        <p:spPr>
+          <a:xfrm>
+            <a:off x="6554972" y="2595181"/>
+            <a:ext cx="1146103" cy="329943"/>
+          </a:xfrm>
+          <a:prstGeom prst="rect">
+            <a:avLst/>
+          </a:prstGeom>
+          <a:solidFill>
+            <a:schemeClr val="tx1"/>
+          </a:solidFill>
+          <a:ln w="19050">
             <a:solidFill>
-              <a:schemeClr val="bg1"/>
+              <a:srgbClr val="0106C7"/>
             </a:solidFill>
           </a:ln>
         </p:spPr>
@@ -15541,22 +15929,22 @@
           <a:p>
             <a:pPr algn="ctr"/>
             <a:r>
-              <a:rPr lang="en-US" sz="1400" dirty="0">
+              <a:rPr lang="en-US" sz="800" dirty="0">
                 <a:solidFill>
                   <a:schemeClr val="bg1"/>
                 </a:solidFill>
               </a:rPr>
-              <a:t>Class PEMFC</a:t>
+              <a:t>initialize.py</a:t>
             </a:r>
           </a:p>
         </p:txBody>
       </p:sp>
       <p:sp>
         <p:nvSpPr>
-          <p:cNvPr id="35" name="Rectangle: Rounded Corners 34">
+          <p:cNvPr id="33" name="Rectangle 32">
             <a:extLst>
               <a:ext uri="{FF2B5EF4-FFF2-40B4-BE49-F238E27FC236}">
-                <a16:creationId xmlns:a16="http://schemas.microsoft.com/office/drawing/2014/main" id="{64B2B24A-EAE2-44B1-36F9-FE08D31DF68C}"/>
+                <a16:creationId xmlns:a16="http://schemas.microsoft.com/office/drawing/2014/main" id="{9326456B-168E-3426-8081-894E5192D226}"/>
               </a:ext>
             </a:extLst>
           </p:cNvPr>
@@ -15565,16 +15953,18 @@
         </p:nvSpPr>
         <p:spPr>
           <a:xfrm>
-            <a:off x="4780790" y="2614764"/>
-            <a:ext cx="1630680" cy="630936"/>
+            <a:off x="6554972" y="2125915"/>
+            <a:ext cx="1146103" cy="329943"/>
           </a:xfrm>
-          <a:prstGeom prst="roundRect">
+          <a:prstGeom prst="rect">
             <a:avLst/>
           </a:prstGeom>
-          <a:noFill/>
-          <a:ln>
+          <a:solidFill>
+            <a:schemeClr val="tx1"/>
+          </a:solidFill>
+          <a:ln w="19050">
             <a:solidFill>
-              <a:schemeClr val="bg1"/>
+              <a:srgbClr val="0106C7"/>
             </a:solidFill>
           </a:ln>
         </p:spPr>
@@ -15600,22 +15990,22 @@
           <a:p>
             <a:pPr algn="ctr"/>
             <a:r>
-              <a:rPr lang="en-US" sz="1400" dirty="0">
+              <a:rPr lang="en-US" sz="800" dirty="0">
                 <a:solidFill>
                   <a:schemeClr val="bg1"/>
                 </a:solidFill>
               </a:rPr>
-              <a:t>Control command</a:t>
+              <a:t>settings.py</a:t>
             </a:r>
           </a:p>
         </p:txBody>
       </p:sp>
       <p:sp>
         <p:nvSpPr>
-          <p:cNvPr id="36" name="Rectangle: Rounded Corners 35">
+          <p:cNvPr id="63" name="Rectangle 62">
             <a:extLst>
               <a:ext uri="{FF2B5EF4-FFF2-40B4-BE49-F238E27FC236}">
-                <a16:creationId xmlns:a16="http://schemas.microsoft.com/office/drawing/2014/main" id="{3A2C052C-54CF-2EB7-7D60-34A2981FC748}"/>
+                <a16:creationId xmlns:a16="http://schemas.microsoft.com/office/drawing/2014/main" id="{7CC92832-BCA0-DBBD-69FF-F2A7C08D5AE5}"/>
               </a:ext>
             </a:extLst>
           </p:cNvPr>
@@ -15624,16 +16014,20 @@
         </p:nvSpPr>
         <p:spPr>
           <a:xfrm>
-            <a:off x="6760468" y="2614764"/>
-            <a:ext cx="1630680" cy="630936"/>
+            <a:off x="5024021" y="1130932"/>
+            <a:ext cx="1146103" cy="329943"/>
           </a:xfrm>
-          <a:prstGeom prst="roundRect">
+          <a:prstGeom prst="rect">
             <a:avLst/>
           </a:prstGeom>
-          <a:noFill/>
-          <a:ln>
+          <a:solidFill>
+            <a:schemeClr val="tx1"/>
+          </a:solidFill>
+          <a:ln w="19050">
             <a:solidFill>
-              <a:schemeClr val="bg1"/>
+              <a:schemeClr val="accent3">
+                <a:lumMod val="75000"/>
+              </a:schemeClr>
             </a:solidFill>
           </a:ln>
         </p:spPr>
@@ -15659,22 +16053,68 @@
           <a:p>
             <a:pPr algn="ctr"/>
             <a:r>
-              <a:rPr lang="en-US" sz="1400" dirty="0">
+              <a:rPr lang="en-US" sz="800" dirty="0">
                 <a:solidFill>
                   <a:schemeClr val="bg1"/>
                 </a:solidFill>
               </a:rPr>
-              <a:t>Display</a:t>
+              <a:t>GUI.py</a:t>
             </a:r>
           </a:p>
         </p:txBody>
       </p:sp>
+      <p:cxnSp>
+        <p:nvCxnSpPr>
+          <p:cNvPr id="69" name="Straight Arrow Connector 68">
+            <a:extLst>
+              <a:ext uri="{FF2B5EF4-FFF2-40B4-BE49-F238E27FC236}">
+                <a16:creationId xmlns:a16="http://schemas.microsoft.com/office/drawing/2014/main" id="{11CBC681-6E2D-0515-ADB8-FE61E3A17C92}"/>
+              </a:ext>
+            </a:extLst>
+          </p:cNvPr>
+          <p:cNvCxnSpPr>
+            <a:cxnSpLocks/>
+            <a:stCxn id="13" idx="0"/>
+            <a:endCxn id="63" idx="2"/>
+          </p:cNvCxnSpPr>
+          <p:nvPr/>
+        </p:nvCxnSpPr>
+        <p:spPr>
+          <a:xfrm flipV="1">
+            <a:off x="5597072" y="1460875"/>
+            <a:ext cx="1" cy="193054"/>
+          </a:xfrm>
+          <a:prstGeom prst="straightConnector1">
+            <a:avLst/>
+          </a:prstGeom>
+          <a:ln w="19050">
+            <a:solidFill>
+              <a:srgbClr val="29BD2D"/>
+            </a:solidFill>
+            <a:tailEnd type="triangle"/>
+          </a:ln>
+        </p:spPr>
+        <p:style>
+          <a:lnRef idx="1">
+            <a:schemeClr val="accent1"/>
+          </a:lnRef>
+          <a:fillRef idx="0">
+            <a:schemeClr val="accent1"/>
+          </a:fillRef>
+          <a:effectRef idx="0">
+            <a:schemeClr val="accent1"/>
+          </a:effectRef>
+          <a:fontRef idx="minor">
+            <a:schemeClr val="tx1"/>
+          </a:fontRef>
+        </p:style>
+      </p:cxnSp>
       <p:sp>
         <p:nvSpPr>
-          <p:cNvPr id="37" name="Rectangle: Rounded Corners 36">
+          <p:cNvPr id="72" name="Rectangle: Rounded Corners 71">
             <a:extLst>
               <a:ext uri="{FF2B5EF4-FFF2-40B4-BE49-F238E27FC236}">
-                <a16:creationId xmlns:a16="http://schemas.microsoft.com/office/drawing/2014/main" id="{5EE81565-D25B-D1AA-ECDD-FB040126134D}"/>
+                <a16:creationId xmlns:a16="http://schemas.microsoft.com/office/drawing/2014/main" id="{EF932B07-D5E6-D78C-F475-F078907EDE91}"/>
               </a:ext>
             </a:extLst>
           </p:cNvPr>
@@ -15683,16 +16123,116 @@
         </p:nvSpPr>
         <p:spPr>
           <a:xfrm>
-            <a:off x="4780790" y="3584550"/>
-            <a:ext cx="1630680" cy="630936"/>
+            <a:off x="3283323" y="1907248"/>
+            <a:ext cx="1559859" cy="1291470"/>
           </a:xfrm>
           <a:prstGeom prst="roundRect">
+            <a:avLst>
+              <a:gd name="adj" fmla="val 7782"/>
+            </a:avLst>
+          </a:prstGeom>
+          <a:noFill/>
+          <a:ln w="9525" cap="flat" cmpd="sng" algn="ctr">
+            <a:solidFill>
+              <a:schemeClr val="dk1"/>
+            </a:solidFill>
+            <a:prstDash val="dash"/>
+            <a:round/>
+            <a:headEnd type="none" w="med" len="med"/>
+            <a:tailEnd type="none" w="med" len="med"/>
+          </a:ln>
+        </p:spPr>
+        <p:style>
+          <a:lnRef idx="0">
+            <a:scrgbClr r="0" g="0" b="0"/>
+          </a:lnRef>
+          <a:fillRef idx="0">
+            <a:scrgbClr r="0" g="0" b="0"/>
+          </a:fillRef>
+          <a:effectRef idx="0">
+            <a:scrgbClr r="0" g="0" b="0"/>
+          </a:effectRef>
+          <a:fontRef idx="minor">
+            <a:schemeClr val="dk1"/>
+          </a:fontRef>
+        </p:style>
+        <p:txBody>
+          <a:bodyPr rtlCol="0" anchor="ctr"/>
+          <a:lstStyle/>
+          <a:p>
+            <a:pPr algn="ctr"/>
+            <a:endParaRPr lang="en-US"/>
+          </a:p>
+        </p:txBody>
+      </p:sp>
+      <p:sp>
+        <p:nvSpPr>
+          <p:cNvPr id="73" name="TextBox 72">
+            <a:extLst>
+              <a:ext uri="{FF2B5EF4-FFF2-40B4-BE49-F238E27FC236}">
+                <a16:creationId xmlns:a16="http://schemas.microsoft.com/office/drawing/2014/main" id="{B6C3CB3E-917A-246B-F9AC-1E35AD4903A8}"/>
+              </a:ext>
+            </a:extLst>
+          </p:cNvPr>
+          <p:cNvSpPr txBox="1"/>
+          <p:nvPr/>
+        </p:nvSpPr>
+        <p:spPr>
+          <a:xfrm>
+            <a:off x="3630804" y="2991468"/>
+            <a:ext cx="737702" cy="246221"/>
+          </a:xfrm>
+          <a:prstGeom prst="rect">
             <a:avLst/>
           </a:prstGeom>
           <a:noFill/>
-          <a:ln>
+        </p:spPr>
+        <p:txBody>
+          <a:bodyPr wrap="none" rtlCol="0">
+            <a:spAutoFit/>
+          </a:bodyPr>
+          <a:lstStyle/>
+          <a:p>
+            <a:pPr algn="ctr"/>
+            <a:r>
+              <a:rPr lang="en-US" sz="1000" dirty="0">
+                <a:solidFill>
+                  <a:schemeClr val="bg1"/>
+                </a:solidFill>
+              </a:rPr>
+              <a:t>./modules</a:t>
+            </a:r>
+          </a:p>
+        </p:txBody>
+      </p:sp>
+      <p:sp>
+        <p:nvSpPr>
+          <p:cNvPr id="74" name="Rectangle 73">
+            <a:extLst>
+              <a:ext uri="{FF2B5EF4-FFF2-40B4-BE49-F238E27FC236}">
+                <a16:creationId xmlns:a16="http://schemas.microsoft.com/office/drawing/2014/main" id="{12773036-0E37-DA44-ECA5-6ED33E589C9E}"/>
+              </a:ext>
+            </a:extLst>
+          </p:cNvPr>
+          <p:cNvSpPr/>
+          <p:nvPr/>
+        </p:nvSpPr>
+        <p:spPr>
+          <a:xfrm>
+            <a:off x="3496249" y="2125915"/>
+            <a:ext cx="1146103" cy="329943"/>
+          </a:xfrm>
+          <a:prstGeom prst="rect">
+            <a:avLst/>
+          </a:prstGeom>
+          <a:solidFill>
+            <a:schemeClr val="tx1"/>
+          </a:solidFill>
+          <a:ln w="19050">
             <a:solidFill>
-              <a:schemeClr val="bg1"/>
+              <a:schemeClr val="accent6">
+                <a:lumMod val="75000"/>
+              </a:schemeClr>
             </a:solidFill>
           </a:ln>
         </p:spPr>
@@ -15718,22 +16258,22 @@
           <a:p>
             <a:pPr algn="ctr"/>
             <a:r>
-              <a:rPr lang="en-US" sz="1400" dirty="0">
+              <a:rPr lang="en-US" sz="800" dirty="0">
                 <a:solidFill>
                   <a:schemeClr val="bg1"/>
                 </a:solidFill>
               </a:rPr>
-              <a:t>Micro-scale calibration</a:t>
+              <a:t>display.py</a:t>
             </a:r>
           </a:p>
         </p:txBody>
       </p:sp>
       <p:sp>
         <p:nvSpPr>
-          <p:cNvPr id="38" name="Rectangle: Rounded Corners 37">
+          <p:cNvPr id="83" name="Rectangle 82">
             <a:extLst>
               <a:ext uri="{FF2B5EF4-FFF2-40B4-BE49-F238E27FC236}">
-                <a16:creationId xmlns:a16="http://schemas.microsoft.com/office/drawing/2014/main" id="{5B34456C-248C-937F-3A43-466484B6504E}"/>
+                <a16:creationId xmlns:a16="http://schemas.microsoft.com/office/drawing/2014/main" id="{9319BED1-FCAC-951A-9D11-D69BD52A98CF}"/>
               </a:ext>
             </a:extLst>
           </p:cNvPr>
@@ -15742,16 +16282,20 @@
         </p:nvSpPr>
         <p:spPr>
           <a:xfrm>
-            <a:off x="8740146" y="2614764"/>
-            <a:ext cx="1630680" cy="630936"/>
+            <a:off x="3487272" y="2595181"/>
+            <a:ext cx="1146103" cy="329943"/>
           </a:xfrm>
-          <a:prstGeom prst="roundRect">
+          <a:prstGeom prst="rect">
             <a:avLst/>
           </a:prstGeom>
-          <a:noFill/>
-          <a:ln>
+          <a:solidFill>
+            <a:schemeClr val="tx1"/>
+          </a:solidFill>
+          <a:ln w="19050">
             <a:solidFill>
-              <a:schemeClr val="bg1"/>
+              <a:schemeClr val="accent6">
+                <a:lumMod val="75000"/>
+              </a:schemeClr>
             </a:solidFill>
           </a:ln>
         </p:spPr>
@@ -15777,22 +16321,22 @@
           <a:p>
             <a:pPr algn="ctr"/>
             <a:r>
-              <a:rPr lang="en-US" sz="1400" dirty="0">
+              <a:rPr lang="en-US" sz="800" dirty="0">
                 <a:solidFill>
                   <a:schemeClr val="bg1"/>
                 </a:solidFill>
               </a:rPr>
-              <a:t>Data</a:t>
+              <a:t>calibration.py</a:t>
             </a:r>
           </a:p>
         </p:txBody>
       </p:sp>
       <p:sp>
         <p:nvSpPr>
-          <p:cNvPr id="39" name="Rectangle: Rounded Corners 38">
+          <p:cNvPr id="113" name="Rectangle: Rounded Corners 112">
             <a:extLst>
               <a:ext uri="{FF2B5EF4-FFF2-40B4-BE49-F238E27FC236}">
-                <a16:creationId xmlns:a16="http://schemas.microsoft.com/office/drawing/2014/main" id="{68F157D1-6C6E-CE0D-0EE7-915BF1B7BBF9}"/>
+                <a16:creationId xmlns:a16="http://schemas.microsoft.com/office/drawing/2014/main" id="{3108F002-4050-F530-C0BB-E03029C903F3}"/>
               </a:ext>
             </a:extLst>
           </p:cNvPr>
@@ -15801,33 +16345,37 @@
         </p:nvSpPr>
         <p:spPr>
           <a:xfrm>
-            <a:off x="6760468" y="3584550"/>
-            <a:ext cx="1630680" cy="630936"/>
+            <a:off x="3047964" y="1135680"/>
+            <a:ext cx="1512712" cy="325195"/>
           </a:xfrm>
           <a:prstGeom prst="roundRect">
-            <a:avLst/>
+            <a:avLst>
+              <a:gd name="adj" fmla="val 7782"/>
+            </a:avLst>
           </a:prstGeom>
           <a:noFill/>
-          <a:ln>
+          <a:ln w="9525" cap="flat" cmpd="sng" algn="ctr">
             <a:solidFill>
-              <a:schemeClr val="bg1"/>
+              <a:srgbClr val="941885"/>
             </a:solidFill>
+            <a:prstDash val="dash"/>
+            <a:round/>
+            <a:headEnd type="none" w="med" len="med"/>
+            <a:tailEnd type="none" w="med" len="med"/>
           </a:ln>
         </p:spPr>
         <p:style>
-          <a:lnRef idx="2">
-            <a:schemeClr val="accent1">
-              <a:shade val="15000"/>
-            </a:schemeClr>
+          <a:lnRef idx="0">
+            <a:scrgbClr r="0" g="0" b="0"/>
           </a:lnRef>
-          <a:fillRef idx="1">
-            <a:schemeClr val="accent1"/>
+          <a:fillRef idx="0">
+            <a:scrgbClr r="0" g="0" b="0"/>
           </a:fillRef>
           <a:effectRef idx="0">
-            <a:schemeClr val="accent1"/>
+            <a:scrgbClr r="0" g="0" b="0"/>
           </a:effectRef>
           <a:fontRef idx="minor">
-            <a:schemeClr val="lt1"/>
+            <a:schemeClr val="dk1"/>
           </a:fontRef>
         </p:style>
         <p:txBody>
@@ -15835,34 +16383,435 @@
           <a:lstStyle/>
           <a:p>
             <a:pPr algn="ctr"/>
-            <a:r>
-              <a:rPr lang="en-US" sz="1400" dirty="0">
-                <a:solidFill>
-                  <a:schemeClr val="bg1"/>
-                </a:solidFill>
-              </a:rPr>
-              <a:t>Macro-scale</a:t>
-            </a:r>
+            <a:endParaRPr lang="en-US"/>
           </a:p>
+        </p:txBody>
+      </p:sp>
+      <p:sp>
+        <p:nvSpPr>
+          <p:cNvPr id="114" name="TextBox 113">
+            <a:extLst>
+              <a:ext uri="{FF2B5EF4-FFF2-40B4-BE49-F238E27FC236}">
+                <a16:creationId xmlns:a16="http://schemas.microsoft.com/office/drawing/2014/main" id="{99C50A88-020E-08CD-C0A2-EEBE42D7ACBC}"/>
+              </a:ext>
+            </a:extLst>
+          </p:cNvPr>
+          <p:cNvSpPr txBox="1"/>
+          <p:nvPr/>
+        </p:nvSpPr>
+        <p:spPr>
+          <a:xfrm>
+            <a:off x="3490936" y="1163788"/>
+            <a:ext cx="569388" cy="276999"/>
+          </a:xfrm>
+          <a:prstGeom prst="rect">
+            <a:avLst/>
+          </a:prstGeom>
+          <a:noFill/>
+        </p:spPr>
+        <p:txBody>
+          <a:bodyPr wrap="none" rtlCol="0">
+            <a:spAutoFit/>
+          </a:bodyPr>
+          <a:lstStyle/>
           <a:p>
             <a:pPr algn="ctr"/>
             <a:r>
-              <a:rPr lang="en-US" sz="1400" dirty="0">
+              <a:rPr lang="en-US" sz="1200" dirty="0">
                 <a:solidFill>
                   <a:schemeClr val="bg1"/>
                 </a:solidFill>
               </a:rPr>
-              <a:t>calibration</a:t>
+              <a:t>./data</a:t>
+            </a:r>
+          </a:p>
+        </p:txBody>
+      </p:sp>
+      <p:cxnSp>
+        <p:nvCxnSpPr>
+          <p:cNvPr id="116" name="Straight Arrow Connector 115">
+            <a:extLst>
+              <a:ext uri="{FF2B5EF4-FFF2-40B4-BE49-F238E27FC236}">
+                <a16:creationId xmlns:a16="http://schemas.microsoft.com/office/drawing/2014/main" id="{5C683000-429F-4E3A-41B4-A77DCAC8E4D6}"/>
+              </a:ext>
+            </a:extLst>
+          </p:cNvPr>
+          <p:cNvCxnSpPr>
+            <a:stCxn id="113" idx="3"/>
+            <a:endCxn id="63" idx="1"/>
+          </p:cNvCxnSpPr>
+          <p:nvPr/>
+        </p:nvCxnSpPr>
+        <p:spPr>
+          <a:xfrm flipV="1">
+            <a:off x="4560676" y="1295904"/>
+            <a:ext cx="463345" cy="2374"/>
+          </a:xfrm>
+          <a:prstGeom prst="straightConnector1">
+            <a:avLst/>
+          </a:prstGeom>
+          <a:ln w="9525">
+            <a:solidFill>
+              <a:srgbClr val="941885"/>
+            </a:solidFill>
+            <a:tailEnd type="triangle"/>
+          </a:ln>
+        </p:spPr>
+        <p:style>
+          <a:lnRef idx="1">
+            <a:schemeClr val="accent1"/>
+          </a:lnRef>
+          <a:fillRef idx="0">
+            <a:schemeClr val="accent1"/>
+          </a:fillRef>
+          <a:effectRef idx="0">
+            <a:schemeClr val="accent1"/>
+          </a:effectRef>
+          <a:fontRef idx="minor">
+            <a:schemeClr val="tx1"/>
+          </a:fontRef>
+        </p:style>
+      </p:cxnSp>
+      <p:cxnSp>
+        <p:nvCxnSpPr>
+          <p:cNvPr id="117" name="Connector: Elbow 116">
+            <a:extLst>
+              <a:ext uri="{FF2B5EF4-FFF2-40B4-BE49-F238E27FC236}">
+                <a16:creationId xmlns:a16="http://schemas.microsoft.com/office/drawing/2014/main" id="{EA24BFD7-431E-3914-00C3-1CF1625C4CD4}"/>
+              </a:ext>
+            </a:extLst>
+          </p:cNvPr>
+          <p:cNvCxnSpPr>
+            <a:cxnSpLocks/>
+            <a:stCxn id="83" idx="1"/>
+            <a:endCxn id="113" idx="1"/>
+          </p:cNvCxnSpPr>
+          <p:nvPr/>
+        </p:nvCxnSpPr>
+        <p:spPr>
+          <a:xfrm rot="10800000">
+            <a:off x="3047964" y="1298279"/>
+            <a:ext cx="439308" cy="1461875"/>
+          </a:xfrm>
+          <a:prstGeom prst="bentConnector3">
+            <a:avLst>
+              <a:gd name="adj1" fmla="val 152036"/>
+            </a:avLst>
+          </a:prstGeom>
+          <a:ln w="9525">
+            <a:solidFill>
+              <a:srgbClr val="941885"/>
+            </a:solidFill>
+            <a:headEnd type="triangle" w="med" len="med"/>
+            <a:tailEnd type="none" w="med" len="med"/>
+          </a:ln>
+        </p:spPr>
+        <p:style>
+          <a:lnRef idx="1">
+            <a:schemeClr val="accent1"/>
+          </a:lnRef>
+          <a:fillRef idx="0">
+            <a:schemeClr val="accent1"/>
+          </a:fillRef>
+          <a:effectRef idx="0">
+            <a:schemeClr val="accent1"/>
+          </a:effectRef>
+          <a:fontRef idx="minor">
+            <a:schemeClr val="tx1"/>
+          </a:fontRef>
+        </p:style>
+      </p:cxnSp>
+      <p:cxnSp>
+        <p:nvCxnSpPr>
+          <p:cNvPr id="126" name="Straight Connector 125">
+            <a:extLst>
+              <a:ext uri="{FF2B5EF4-FFF2-40B4-BE49-F238E27FC236}">
+                <a16:creationId xmlns:a16="http://schemas.microsoft.com/office/drawing/2014/main" id="{6173F33A-3607-8AE6-2C28-5FAC119A5D34}"/>
+              </a:ext>
+            </a:extLst>
+          </p:cNvPr>
+          <p:cNvCxnSpPr/>
+          <p:nvPr/>
+        </p:nvCxnSpPr>
+        <p:spPr>
+          <a:xfrm>
+            <a:off x="3466395" y="5883419"/>
+            <a:ext cx="548640" cy="0"/>
+          </a:xfrm>
+          <a:prstGeom prst="line">
+            <a:avLst/>
+          </a:prstGeom>
+          <a:ln>
+            <a:solidFill>
+              <a:schemeClr val="bg1"/>
+            </a:solidFill>
+            <a:prstDash val="dash"/>
+          </a:ln>
+        </p:spPr>
+        <p:style>
+          <a:lnRef idx="1">
+            <a:schemeClr val="accent1"/>
+          </a:lnRef>
+          <a:fillRef idx="0">
+            <a:schemeClr val="accent1"/>
+          </a:fillRef>
+          <a:effectRef idx="0">
+            <a:schemeClr val="accent1"/>
+          </a:effectRef>
+          <a:fontRef idx="minor">
+            <a:schemeClr val="tx1"/>
+          </a:fontRef>
+        </p:style>
+      </p:cxnSp>
+      <p:sp>
+        <p:nvSpPr>
+          <p:cNvPr id="127" name="TextBox 126">
+            <a:extLst>
+              <a:ext uri="{FF2B5EF4-FFF2-40B4-BE49-F238E27FC236}">
+                <a16:creationId xmlns:a16="http://schemas.microsoft.com/office/drawing/2014/main" id="{229FF082-9413-413E-7151-2813E7D50A88}"/>
+              </a:ext>
+            </a:extLst>
+          </p:cNvPr>
+          <p:cNvSpPr txBox="1"/>
+          <p:nvPr/>
+        </p:nvSpPr>
+        <p:spPr>
+          <a:xfrm>
+            <a:off x="4061895" y="5747794"/>
+            <a:ext cx="607859" cy="261610"/>
+          </a:xfrm>
+          <a:prstGeom prst="rect">
+            <a:avLst/>
+          </a:prstGeom>
+          <a:noFill/>
+        </p:spPr>
+        <p:txBody>
+          <a:bodyPr wrap="none" rtlCol="0">
+            <a:spAutoFit/>
+          </a:bodyPr>
+          <a:lstStyle/>
+          <a:p>
+            <a:r>
+              <a:rPr lang="en-US" sz="1100" dirty="0">
+                <a:solidFill>
+                  <a:schemeClr val="bg1"/>
+                </a:solidFill>
+              </a:rPr>
+              <a:t>folders</a:t>
+            </a:r>
+          </a:p>
+        </p:txBody>
+      </p:sp>
+      <p:cxnSp>
+        <p:nvCxnSpPr>
+          <p:cNvPr id="128" name="Straight Connector 127">
+            <a:extLst>
+              <a:ext uri="{FF2B5EF4-FFF2-40B4-BE49-F238E27FC236}">
+                <a16:creationId xmlns:a16="http://schemas.microsoft.com/office/drawing/2014/main" id="{833436DD-C959-573B-0BA5-D415A1584006}"/>
+              </a:ext>
+            </a:extLst>
+          </p:cNvPr>
+          <p:cNvCxnSpPr/>
+          <p:nvPr/>
+        </p:nvCxnSpPr>
+        <p:spPr>
+          <a:xfrm>
+            <a:off x="4836609" y="5870323"/>
+            <a:ext cx="548640" cy="0"/>
+          </a:xfrm>
+          <a:prstGeom prst="line">
+            <a:avLst/>
+          </a:prstGeom>
+          <a:ln>
+            <a:solidFill>
+              <a:schemeClr val="bg1"/>
+            </a:solidFill>
+            <a:prstDash val="solid"/>
+          </a:ln>
+        </p:spPr>
+        <p:style>
+          <a:lnRef idx="1">
+            <a:schemeClr val="accent1"/>
+          </a:lnRef>
+          <a:fillRef idx="0">
+            <a:schemeClr val="accent1"/>
+          </a:fillRef>
+          <a:effectRef idx="0">
+            <a:schemeClr val="accent1"/>
+          </a:effectRef>
+          <a:fontRef idx="minor">
+            <a:schemeClr val="tx1"/>
+          </a:fontRef>
+        </p:style>
+      </p:cxnSp>
+      <p:sp>
+        <p:nvSpPr>
+          <p:cNvPr id="129" name="TextBox 128">
+            <a:extLst>
+              <a:ext uri="{FF2B5EF4-FFF2-40B4-BE49-F238E27FC236}">
+                <a16:creationId xmlns:a16="http://schemas.microsoft.com/office/drawing/2014/main" id="{D5D9EB0E-873A-F9EF-36CC-6C1C777EA1AE}"/>
+              </a:ext>
+            </a:extLst>
+          </p:cNvPr>
+          <p:cNvSpPr txBox="1"/>
+          <p:nvPr/>
+        </p:nvSpPr>
+        <p:spPr>
+          <a:xfrm>
+            <a:off x="5421668" y="5747794"/>
+            <a:ext cx="436338" cy="261610"/>
+          </a:xfrm>
+          <a:prstGeom prst="rect">
+            <a:avLst/>
+          </a:prstGeom>
+          <a:noFill/>
+        </p:spPr>
+        <p:txBody>
+          <a:bodyPr wrap="none" rtlCol="0">
+            <a:spAutoFit/>
+          </a:bodyPr>
+          <a:lstStyle/>
+          <a:p>
+            <a:r>
+              <a:rPr lang="en-US" sz="1100" dirty="0">
+                <a:solidFill>
+                  <a:schemeClr val="bg1"/>
+                </a:solidFill>
+              </a:rPr>
+              <a:t>files</a:t>
             </a:r>
           </a:p>
         </p:txBody>
       </p:sp>
       <p:sp>
         <p:nvSpPr>
-          <p:cNvPr id="40" name="Rectangle: Rounded Corners 39">
+          <p:cNvPr id="130" name="TextBox 129">
             <a:extLst>
               <a:ext uri="{FF2B5EF4-FFF2-40B4-BE49-F238E27FC236}">
-                <a16:creationId xmlns:a16="http://schemas.microsoft.com/office/drawing/2014/main" id="{1C0E377A-FD69-CDB8-8627-DF704234FD27}"/>
+                <a16:creationId xmlns:a16="http://schemas.microsoft.com/office/drawing/2014/main" id="{0077B6B5-6D72-9922-1814-C54A991AD5EC}"/>
+              </a:ext>
+            </a:extLst>
+          </p:cNvPr>
+          <p:cNvSpPr txBox="1"/>
+          <p:nvPr/>
+        </p:nvSpPr>
+        <p:spPr>
+          <a:xfrm>
+            <a:off x="2999204" y="413232"/>
+            <a:ext cx="5195734" cy="369332"/>
+          </a:xfrm>
+          <a:prstGeom prst="rect">
+            <a:avLst/>
+          </a:prstGeom>
+          <a:noFill/>
+        </p:spPr>
+        <p:txBody>
+          <a:bodyPr wrap="square" rtlCol="0">
+            <a:spAutoFit/>
+          </a:bodyPr>
+          <a:lstStyle/>
+          <a:p>
+            <a:pPr algn="ctr"/>
+            <a:r>
+              <a:rPr lang="en-US" b="1" dirty="0">
+                <a:solidFill>
+                  <a:schemeClr val="bg1"/>
+                </a:solidFill>
+              </a:rPr>
+              <a:t>Software framework</a:t>
+            </a:r>
+          </a:p>
+        </p:txBody>
+      </p:sp>
+      <p:cxnSp>
+        <p:nvCxnSpPr>
+          <p:cNvPr id="131" name="Straight Connector 130">
+            <a:extLst>
+              <a:ext uri="{FF2B5EF4-FFF2-40B4-BE49-F238E27FC236}">
+                <a16:creationId xmlns:a16="http://schemas.microsoft.com/office/drawing/2014/main" id="{1786D0BE-40EE-0B3F-5595-FC2B73A2B848}"/>
+              </a:ext>
+            </a:extLst>
+          </p:cNvPr>
+          <p:cNvCxnSpPr/>
+          <p:nvPr/>
+        </p:nvCxnSpPr>
+        <p:spPr>
+          <a:xfrm>
+            <a:off x="6024861" y="5862461"/>
+            <a:ext cx="548640" cy="0"/>
+          </a:xfrm>
+          <a:prstGeom prst="line">
+            <a:avLst/>
+          </a:prstGeom>
+          <a:ln>
+            <a:solidFill>
+              <a:schemeClr val="bg1"/>
+            </a:solidFill>
+            <a:prstDash val="solid"/>
+            <a:headEnd type="none" w="med" len="med"/>
+            <a:tailEnd type="triangle" w="med" len="med"/>
+          </a:ln>
+        </p:spPr>
+        <p:style>
+          <a:lnRef idx="1">
+            <a:schemeClr val="accent1"/>
+          </a:lnRef>
+          <a:fillRef idx="0">
+            <a:schemeClr val="accent1"/>
+          </a:fillRef>
+          <a:effectRef idx="0">
+            <a:schemeClr val="accent1"/>
+          </a:effectRef>
+          <a:fontRef idx="minor">
+            <a:schemeClr val="tx1"/>
+          </a:fontRef>
+        </p:style>
+      </p:cxnSp>
+      <p:sp>
+        <p:nvSpPr>
+          <p:cNvPr id="132" name="TextBox 131">
+            <a:extLst>
+              <a:ext uri="{FF2B5EF4-FFF2-40B4-BE49-F238E27FC236}">
+                <a16:creationId xmlns:a16="http://schemas.microsoft.com/office/drawing/2014/main" id="{3B45CE09-059F-58D2-023C-9060F7D22677}"/>
+              </a:ext>
+            </a:extLst>
+          </p:cNvPr>
+          <p:cNvSpPr txBox="1"/>
+          <p:nvPr/>
+        </p:nvSpPr>
+        <p:spPr>
+          <a:xfrm>
+            <a:off x="6609920" y="5739932"/>
+            <a:ext cx="954107" cy="261610"/>
+          </a:xfrm>
+          <a:prstGeom prst="rect">
+            <a:avLst/>
+          </a:prstGeom>
+          <a:noFill/>
+        </p:spPr>
+        <p:txBody>
+          <a:bodyPr wrap="none" rtlCol="0">
+            <a:spAutoFit/>
+          </a:bodyPr>
+          <a:lstStyle/>
+          <a:p>
+            <a:r>
+              <a:rPr lang="en-US" sz="1100" dirty="0">
+                <a:solidFill>
+                  <a:schemeClr val="bg1"/>
+                </a:solidFill>
+              </a:rPr>
+              <a:t>dependency</a:t>
+            </a:r>
+          </a:p>
+        </p:txBody>
+      </p:sp>
+      <p:sp>
+        <p:nvSpPr>
+          <p:cNvPr id="133" name="Rectangle: Rounded Corners 132">
+            <a:extLst>
+              <a:ext uri="{FF2B5EF4-FFF2-40B4-BE49-F238E27FC236}">
+                <a16:creationId xmlns:a16="http://schemas.microsoft.com/office/drawing/2014/main" id="{BC2604B9-44F2-35A5-EA55-53CB7CC4388C}"/>
               </a:ext>
             </a:extLst>
           </p:cNvPr>
@@ -15871,33 +16820,37 @@
         </p:nvSpPr>
         <p:spPr>
           <a:xfrm>
-            <a:off x="4780790" y="4558380"/>
-            <a:ext cx="1630680" cy="630936"/>
+            <a:off x="2370666" y="355831"/>
+            <a:ext cx="6350001" cy="5685002"/>
           </a:xfrm>
           <a:prstGeom prst="roundRect">
-            <a:avLst/>
+            <a:avLst>
+              <a:gd name="adj" fmla="val 7450"/>
+            </a:avLst>
           </a:prstGeom>
           <a:noFill/>
-          <a:ln>
+          <a:ln w="9525" cap="flat" cmpd="sng" algn="ctr">
             <a:solidFill>
-              <a:schemeClr val="bg1"/>
+              <a:schemeClr val="dk1"/>
             </a:solidFill>
+            <a:prstDash val="solid"/>
+            <a:round/>
+            <a:headEnd type="none" w="med" len="med"/>
+            <a:tailEnd type="none" w="med" len="med"/>
           </a:ln>
         </p:spPr>
         <p:style>
-          <a:lnRef idx="2">
-            <a:schemeClr val="accent1">
-              <a:shade val="15000"/>
-            </a:schemeClr>
+          <a:lnRef idx="0">
+            <a:scrgbClr r="0" g="0" b="0"/>
           </a:lnRef>
-          <a:fillRef idx="1">
-            <a:schemeClr val="accent1"/>
+          <a:fillRef idx="0">
+            <a:scrgbClr r="0" g="0" b="0"/>
           </a:fillRef>
           <a:effectRef idx="0">
-            <a:schemeClr val="accent1"/>
+            <a:scrgbClr r="0" g="0" b="0"/>
           </a:effectRef>
           <a:fontRef idx="minor">
-            <a:schemeClr val="lt1"/>
+            <a:schemeClr val="dk1"/>
           </a:fontRef>
         </p:style>
         <p:txBody>
@@ -15905,106 +16858,377 @@
           <a:lstStyle/>
           <a:p>
             <a:pPr algn="ctr"/>
-            <a:r>
-              <a:rPr lang="en-US" sz="1400" dirty="0">
-                <a:solidFill>
-                  <a:schemeClr val="bg1"/>
-                </a:solidFill>
-              </a:rPr>
-              <a:t>Experiment data</a:t>
-            </a:r>
+            <a:endParaRPr lang="en-US"/>
           </a:p>
         </p:txBody>
       </p:sp>
-      <p:sp>
-        <p:nvSpPr>
-          <p:cNvPr id="41" name="Rectangle: Rounded Corners 40">
+      <p:cxnSp>
+        <p:nvCxnSpPr>
+          <p:cNvPr id="160" name="Connector: Elbow 159">
             <a:extLst>
               <a:ext uri="{FF2B5EF4-FFF2-40B4-BE49-F238E27FC236}">
-                <a16:creationId xmlns:a16="http://schemas.microsoft.com/office/drawing/2014/main" id="{41FE0B89-A709-01BD-5598-5EB0E8CEC10D}"/>
+                <a16:creationId xmlns:a16="http://schemas.microsoft.com/office/drawing/2014/main" id="{98817F9A-A328-1A8E-3C83-55A978CD66AD}"/>
               </a:ext>
             </a:extLst>
           </p:cNvPr>
-          <p:cNvSpPr/>
+          <p:cNvCxnSpPr>
+            <a:cxnSpLocks/>
+            <a:stCxn id="7" idx="3"/>
+            <a:endCxn id="32" idx="3"/>
+          </p:cNvCxnSpPr>
           <p:nvPr/>
-        </p:nvSpPr>
+        </p:nvCxnSpPr>
         <p:spPr>
-          <a:xfrm>
-            <a:off x="6760468" y="4554336"/>
-            <a:ext cx="1630680" cy="630936"/>
+          <a:xfrm flipV="1">
+            <a:off x="7553568" y="2760153"/>
+            <a:ext cx="147507" cy="2244979"/>
           </a:xfrm>
-          <a:prstGeom prst="roundRect">
-            <a:avLst/>
+          <a:prstGeom prst="bentConnector3">
+            <a:avLst>
+              <a:gd name="adj1" fmla="val 361565"/>
+            </a:avLst>
           </a:prstGeom>
-          <a:noFill/>
-          <a:ln>
+          <a:ln w="19050">
             <a:solidFill>
               <a:schemeClr val="bg1"/>
             </a:solidFill>
+            <a:tailEnd type="triangle"/>
           </a:ln>
         </p:spPr>
         <p:style>
-          <a:lnRef idx="2">
-            <a:schemeClr val="accent1">
-              <a:shade val="15000"/>
-            </a:schemeClr>
+          <a:lnRef idx="1">
+            <a:schemeClr val="accent1"/>
           </a:lnRef>
-          <a:fillRef idx="1">
+          <a:fillRef idx="0">
             <a:schemeClr val="accent1"/>
           </a:fillRef>
           <a:effectRef idx="0">
             <a:schemeClr val="accent1"/>
           </a:effectRef>
           <a:fontRef idx="minor">
-            <a:schemeClr val="lt1"/>
+            <a:schemeClr val="tx1"/>
           </a:fontRef>
         </p:style>
-        <p:txBody>
-          <a:bodyPr rtlCol="0" anchor="ctr"/>
-          <a:lstStyle/>
-          <a:p>
-            <a:pPr algn="ctr"/>
-            <a:r>
-              <a:rPr lang="en-US" sz="1400" dirty="0">
-                <a:solidFill>
-                  <a:schemeClr val="bg1"/>
-                </a:solidFill>
-              </a:rPr>
-              <a:t>Literature data</a:t>
-            </a:r>
-          </a:p>
-        </p:txBody>
-      </p:sp>
-    </p:spTree>
-    <p:extLst>
-      <p:ext uri="{BB962C8B-B14F-4D97-AF65-F5344CB8AC3E}">
-        <p14:creationId xmlns:p14="http://schemas.microsoft.com/office/powerpoint/2010/main" val="2587050652"/>
-      </p:ext>
-    </p:extLst>
-  </p:cSld>
-  <p:clrMapOvr>
-    <a:masterClrMapping/>
-  </p:clrMapOvr>
-</p:sld>
-</file>
-
-<file path=ppt/slides/slide2.xml><?xml version="1.0" encoding="utf-8"?>
-<p:sld xmlns:a="http://schemas.openxmlformats.org/drawingml/2006/main" xmlns:r="http://schemas.openxmlformats.org/officeDocument/2006/relationships" xmlns:p="http://schemas.openxmlformats.org/presentationml/2006/main">
-  <p:cSld>
-    <p:spTree>
-      <p:nvGrpSpPr>
-        <p:cNvPr id="1" name=""/>
-        <p:cNvGrpSpPr/>
-        <p:nvPr/>
-      </p:nvGrpSpPr>
-      <p:grpSpPr>
-        <a:xfrm>
-          <a:off x="0" y="0"/>
-          <a:ext cx="0" cy="0"/>
-          <a:chOff x="0" y="0"/>
-          <a:chExt cx="0" cy="0"/>
-        </a:xfrm>
-      </p:grpSpPr>
+      </p:cxnSp>
+      <p:cxnSp>
+        <p:nvCxnSpPr>
+          <p:cNvPr id="165" name="Connector: Elbow 164">
+            <a:extLst>
+              <a:ext uri="{FF2B5EF4-FFF2-40B4-BE49-F238E27FC236}">
+                <a16:creationId xmlns:a16="http://schemas.microsoft.com/office/drawing/2014/main" id="{07767D80-5061-7A7F-79ED-8B04F9A66528}"/>
+              </a:ext>
+            </a:extLst>
+          </p:cNvPr>
+          <p:cNvCxnSpPr>
+            <a:cxnSpLocks/>
+            <a:stCxn id="74" idx="0"/>
+          </p:cNvCxnSpPr>
+          <p:nvPr/>
+        </p:nvCxnSpPr>
+        <p:spPr>
+          <a:xfrm rot="5400000" flipH="1" flipV="1">
+            <a:off x="4463605" y="1066571"/>
+            <a:ext cx="665041" cy="1453648"/>
+          </a:xfrm>
+          <a:prstGeom prst="bentConnector3">
+            <a:avLst>
+              <a:gd name="adj1" fmla="val 81107"/>
+            </a:avLst>
+          </a:prstGeom>
+          <a:ln w="19050">
+            <a:solidFill>
+              <a:srgbClr val="799331"/>
+            </a:solidFill>
+            <a:tailEnd type="triangle"/>
+          </a:ln>
+        </p:spPr>
+        <p:style>
+          <a:lnRef idx="1">
+            <a:schemeClr val="accent1"/>
+          </a:lnRef>
+          <a:fillRef idx="0">
+            <a:schemeClr val="accent1"/>
+          </a:fillRef>
+          <a:effectRef idx="0">
+            <a:schemeClr val="accent1"/>
+          </a:effectRef>
+          <a:fontRef idx="minor">
+            <a:schemeClr val="tx1"/>
+          </a:fontRef>
+        </p:style>
+      </p:cxnSp>
+      <p:cxnSp>
+        <p:nvCxnSpPr>
+          <p:cNvPr id="172" name="Straight Arrow Connector 171">
+            <a:extLst>
+              <a:ext uri="{FF2B5EF4-FFF2-40B4-BE49-F238E27FC236}">
+                <a16:creationId xmlns:a16="http://schemas.microsoft.com/office/drawing/2014/main" id="{F997A440-ED48-5C90-227A-69BB3E151422}"/>
+              </a:ext>
+            </a:extLst>
+          </p:cNvPr>
+          <p:cNvCxnSpPr>
+            <a:cxnSpLocks/>
+          </p:cNvCxnSpPr>
+          <p:nvPr/>
+        </p:nvCxnSpPr>
+        <p:spPr>
+          <a:xfrm flipH="1">
+            <a:off x="4642352" y="2341687"/>
+            <a:ext cx="1912620" cy="0"/>
+          </a:xfrm>
+          <a:prstGeom prst="straightConnector1">
+            <a:avLst/>
+          </a:prstGeom>
+          <a:ln w="19050">
+            <a:solidFill>
+              <a:srgbClr val="0106C7"/>
+            </a:solidFill>
+            <a:tailEnd type="triangle"/>
+          </a:ln>
+        </p:spPr>
+        <p:style>
+          <a:lnRef idx="1">
+            <a:schemeClr val="accent1"/>
+          </a:lnRef>
+          <a:fillRef idx="0">
+            <a:schemeClr val="accent1"/>
+          </a:fillRef>
+          <a:effectRef idx="0">
+            <a:schemeClr val="accent1"/>
+          </a:effectRef>
+          <a:fontRef idx="minor">
+            <a:schemeClr val="tx1"/>
+          </a:fontRef>
+        </p:style>
+      </p:cxnSp>
+      <p:cxnSp>
+        <p:nvCxnSpPr>
+          <p:cNvPr id="176" name="Connector: Elbow 175">
+            <a:extLst>
+              <a:ext uri="{FF2B5EF4-FFF2-40B4-BE49-F238E27FC236}">
+                <a16:creationId xmlns:a16="http://schemas.microsoft.com/office/drawing/2014/main" id="{9454C48B-80EB-2DC4-72CF-6349976D9137}"/>
+              </a:ext>
+            </a:extLst>
+          </p:cNvPr>
+          <p:cNvCxnSpPr>
+            <a:cxnSpLocks/>
+            <a:stCxn id="32" idx="1"/>
+          </p:cNvCxnSpPr>
+          <p:nvPr/>
+        </p:nvCxnSpPr>
+        <p:spPr>
+          <a:xfrm rot="10800000">
+            <a:off x="5657944" y="1984101"/>
+            <a:ext cx="897028" cy="776052"/>
+          </a:xfrm>
+          <a:prstGeom prst="bentConnector2">
+            <a:avLst/>
+          </a:prstGeom>
+          <a:ln w="19050">
+            <a:solidFill>
+              <a:srgbClr val="0106C7"/>
+            </a:solidFill>
+            <a:tailEnd type="triangle"/>
+          </a:ln>
+        </p:spPr>
+        <p:style>
+          <a:lnRef idx="1">
+            <a:schemeClr val="accent1"/>
+          </a:lnRef>
+          <a:fillRef idx="0">
+            <a:schemeClr val="accent1"/>
+          </a:fillRef>
+          <a:effectRef idx="0">
+            <a:schemeClr val="accent1"/>
+          </a:effectRef>
+          <a:fontRef idx="minor">
+            <a:schemeClr val="tx1"/>
+          </a:fontRef>
+        </p:style>
+      </p:cxnSp>
+      <p:cxnSp>
+        <p:nvCxnSpPr>
+          <p:cNvPr id="180" name="Connector: Elbow 179">
+            <a:extLst>
+              <a:ext uri="{FF2B5EF4-FFF2-40B4-BE49-F238E27FC236}">
+                <a16:creationId xmlns:a16="http://schemas.microsoft.com/office/drawing/2014/main" id="{EBD36CAD-6BD3-695F-89F6-54D26452B47A}"/>
+              </a:ext>
+            </a:extLst>
+          </p:cNvPr>
+          <p:cNvCxnSpPr>
+            <a:cxnSpLocks/>
+            <a:stCxn id="33" idx="1"/>
+          </p:cNvCxnSpPr>
+          <p:nvPr/>
+        </p:nvCxnSpPr>
+        <p:spPr>
+          <a:xfrm rot="10800000">
+            <a:off x="5718270" y="1984101"/>
+            <a:ext cx="836703" cy="306786"/>
+          </a:xfrm>
+          <a:prstGeom prst="bentConnector2">
+            <a:avLst/>
+          </a:prstGeom>
+          <a:ln w="19050">
+            <a:solidFill>
+              <a:srgbClr val="0106C7"/>
+            </a:solidFill>
+            <a:tailEnd type="triangle"/>
+          </a:ln>
+        </p:spPr>
+        <p:style>
+          <a:lnRef idx="1">
+            <a:schemeClr val="accent1"/>
+          </a:lnRef>
+          <a:fillRef idx="0">
+            <a:schemeClr val="accent1"/>
+          </a:fillRef>
+          <a:effectRef idx="0">
+            <a:schemeClr val="accent1"/>
+          </a:effectRef>
+          <a:fontRef idx="minor">
+            <a:schemeClr val="tx1"/>
+          </a:fontRef>
+        </p:style>
+      </p:cxnSp>
+      <p:cxnSp>
+        <p:nvCxnSpPr>
+          <p:cNvPr id="184" name="Connector: Elbow 183">
+            <a:extLst>
+              <a:ext uri="{FF2B5EF4-FFF2-40B4-BE49-F238E27FC236}">
+                <a16:creationId xmlns:a16="http://schemas.microsoft.com/office/drawing/2014/main" id="{04636FE4-F5B4-71C0-DF33-5C685CC60459}"/>
+              </a:ext>
+            </a:extLst>
+          </p:cNvPr>
+          <p:cNvCxnSpPr>
+            <a:cxnSpLocks/>
+            <a:stCxn id="83" idx="3"/>
+          </p:cNvCxnSpPr>
+          <p:nvPr/>
+        </p:nvCxnSpPr>
+        <p:spPr>
+          <a:xfrm flipV="1">
+            <a:off x="4633375" y="1983872"/>
+            <a:ext cx="895290" cy="776281"/>
+          </a:xfrm>
+          <a:prstGeom prst="bentConnector2">
+            <a:avLst/>
+          </a:prstGeom>
+          <a:ln w="19050">
+            <a:solidFill>
+              <a:srgbClr val="799331"/>
+            </a:solidFill>
+            <a:tailEnd type="triangle"/>
+          </a:ln>
+        </p:spPr>
+        <p:style>
+          <a:lnRef idx="1">
+            <a:schemeClr val="accent1"/>
+          </a:lnRef>
+          <a:fillRef idx="0">
+            <a:schemeClr val="accent1"/>
+          </a:fillRef>
+          <a:effectRef idx="0">
+            <a:schemeClr val="accent1"/>
+          </a:effectRef>
+          <a:fontRef idx="minor">
+            <a:schemeClr val="tx1"/>
+          </a:fontRef>
+        </p:style>
+      </p:cxnSp>
+      <p:cxnSp>
+        <p:nvCxnSpPr>
+          <p:cNvPr id="187" name="Straight Arrow Connector 186">
+            <a:extLst>
+              <a:ext uri="{FF2B5EF4-FFF2-40B4-BE49-F238E27FC236}">
+                <a16:creationId xmlns:a16="http://schemas.microsoft.com/office/drawing/2014/main" id="{203D07C0-0601-6646-58E9-A37C941A8390}"/>
+              </a:ext>
+            </a:extLst>
+          </p:cNvPr>
+          <p:cNvCxnSpPr>
+            <a:cxnSpLocks/>
+            <a:stCxn id="32" idx="0"/>
+            <a:endCxn id="33" idx="2"/>
+          </p:cNvCxnSpPr>
+          <p:nvPr/>
+        </p:nvCxnSpPr>
+        <p:spPr>
+          <a:xfrm flipV="1">
+            <a:off x="7128024" y="2455858"/>
+            <a:ext cx="0" cy="139323"/>
+          </a:xfrm>
+          <a:prstGeom prst="straightConnector1">
+            <a:avLst/>
+          </a:prstGeom>
+          <a:ln w="19050">
+            <a:solidFill>
+              <a:srgbClr val="0106C7"/>
+            </a:solidFill>
+            <a:tailEnd type="triangle"/>
+          </a:ln>
+        </p:spPr>
+        <p:style>
+          <a:lnRef idx="1">
+            <a:schemeClr val="accent1"/>
+          </a:lnRef>
+          <a:fillRef idx="0">
+            <a:schemeClr val="accent1"/>
+          </a:fillRef>
+          <a:effectRef idx="0">
+            <a:schemeClr val="accent1"/>
+          </a:effectRef>
+          <a:fontRef idx="minor">
+            <a:schemeClr val="tx1"/>
+          </a:fontRef>
+        </p:style>
+      </p:cxnSp>
+      <p:cxnSp>
+        <p:nvCxnSpPr>
+          <p:cNvPr id="190" name="Connector: Elbow 189">
+            <a:extLst>
+              <a:ext uri="{FF2B5EF4-FFF2-40B4-BE49-F238E27FC236}">
+                <a16:creationId xmlns:a16="http://schemas.microsoft.com/office/drawing/2014/main" id="{BDE89256-5BB5-66C8-E482-5D1C905FB890}"/>
+              </a:ext>
+            </a:extLst>
+          </p:cNvPr>
+          <p:cNvCxnSpPr>
+            <a:cxnSpLocks/>
+            <a:stCxn id="33" idx="0"/>
+          </p:cNvCxnSpPr>
+          <p:nvPr/>
+        </p:nvCxnSpPr>
+        <p:spPr>
+          <a:xfrm rot="16200000" flipV="1">
+            <a:off x="6060465" y="1058355"/>
+            <a:ext cx="665040" cy="1470079"/>
+          </a:xfrm>
+          <a:prstGeom prst="bentConnector3">
+            <a:avLst>
+              <a:gd name="adj1" fmla="val 81032"/>
+            </a:avLst>
+          </a:prstGeom>
+          <a:ln w="19050">
+            <a:solidFill>
+              <a:srgbClr val="0106C7"/>
+            </a:solidFill>
+            <a:tailEnd type="triangle"/>
+          </a:ln>
+        </p:spPr>
+        <p:style>
+          <a:lnRef idx="1">
+            <a:schemeClr val="accent1"/>
+          </a:lnRef>
+          <a:fillRef idx="0">
+            <a:schemeClr val="accent1"/>
+          </a:fillRef>
+          <a:effectRef idx="0">
+            <a:schemeClr val="accent1"/>
+          </a:effectRef>
+          <a:fontRef idx="minor">
+            <a:schemeClr val="tx1"/>
+          </a:fontRef>
+        </p:style>
+      </p:cxnSp>
     </p:spTree>
     <p:extLst>
       <p:ext uri="{BB962C8B-B14F-4D97-AF65-F5344CB8AC3E}">

</xml_diff>